<commit_message>
deck 2-4: author correction pass — array-access diagram (s4), incompatibility relabel (s5), attached-weakness pipeline (s7), replication principle (s17), control+feedback with documented-vs-hypothetical (s19), copyedits + backtracking contrast (s26) + DOCUMENTED/INTERPRETATION/PROPOSED notes pass (s15-19)
Five required fixes, six copyedits, optional slide-26 visual, and the
epistemic notes pass applied per the author's approval feedback. 28 slides
unchanged in count and order; gates green (validate 0, pptx OPC+schema PASS,
tier1 83/0).

Co-Authored-By: Claude Opus 4.8 (1M context) <noreply@anthropic.com>
</commit_message>
<xml_diff>
--- a/book/_design/2-4-redux-build/2-4-redux-WIP.pptx
+++ b/book/_design/2-4-redux-build/2-4-redux-WIP.pptx
@@ -1427,6 +1427,16 @@
               <a:t>SOURCES: CrowdStrike RCA, 6 Aug 2024, for every number on this slide.</a:t>
             </a:r>
           </a:p>
+          <a:p>
+            <a:r>
+              <a:t>PACING (author): do not over-dwell on the technical mechanism — students need the INTERFACE MISMATCH, not the full Falcon content-processing architecture. Keep the walk-through under two minutes of the five.</a:t>
+            </a:r>
+          </a:p>
+          <a:p>
+            <a:r>
+              <a:t>TERMINOLOGY (stays in notes, off the slide): the Template Type defines the 21 fields; Template Instances are the content built against it; the Content Validator checked instances against the Template Type's 21 fields; the Content Interpreter consumed the integration code's 20-entry input array and, directed by the first non-wildcard 21st matching criterion, attempted the [20] access.</a:t>
+            </a:r>
+          </a:p>
         </p:txBody>
       </p:sp>
       <p:sp>
@@ -1537,6 +1547,11 @@
               <a:t>SOURCES: CrowdStrike RCA, 6 Aug 2024 (the bounds-check mitigation, backported to Windows sensor 7.11 and later).</a:t>
             </a:r>
           </a:p>
+          <a:p>
+            <a:r>
+              <a:t>CORRECTION FOLDED IN: the first node reads 'incompatible content + interpreter', not 'defective content'. This was not a malformed file breaking an otherwise-correct interpreter — it was incompatible assumptions across the template definition, the integration code, the validator, and the interpreter. 'Repair the defect' therefore means repairing the incompatibility, not one content artifact; a content-only fix would leave the same mismatch armed for the next instance.</a:t>
+            </a:r>
+          </a:p>
         </p:txBody>
       </p:sp>
       <p:sp>
@@ -1604,7 +1619,7 @@
           <a:lstStyle/>
           <a:p>
             <a:r>
-              <a:t>TIMING: 4 minutes. MAKE THEM COMMIT BEFORE THEY KNOW MORE.</a:t>
+              <a:t>TIMING: 4 minutes — PROTECT 3 of them for the discussion (author pacing note). MAKE THEM COMMIT BEFORE THEY KNOW MORE.</a:t>
             </a:r>
           </a:p>
           <a:p>
@@ -2499,12 +2514,22 @@
           </a:p>
           <a:p>
             <a:r>
-              <a:t>ENGINEERING POINT: a controller can make an unsafe decision because its process model is inaccurate, its feedback is inadequate, or its available control actions are insufficient — all three without anyone being negligent. For this release, the process model said 'the Content Validator passed it, so it is safe'; that model was wrong about what the validator actually checked (21 fields against the 20 supplied — RCA finding 4).</a:t>
-            </a:r>
-          </a:p>
-          <a:p>
-            <a:r>
-              <a:t>CARE: this is a SIMPLIFIED INSTRUCTIONAL control structure. Do not claim every depicted feedback path existed or operated during the incident, and do not invent telemetry, approvals, or rollout stages the RCA does not document. What the RCA does document: no staged rollout for Template Instances, and a remediation commitment to canary deployment rings with rollback and customer control over Rapid Response Content deployment (CrowdStrike RCA, 6 Aug 2024).</a:t>
+              <a:t>ENGINEERING POINT: a controller can make an unsafe decision because its process model is inaccurate, its feedback is inadequate, or its available control actions are insufficient — all three without anyone being negligent.</a:t>
+            </a:r>
+          </a:p>
+          <a:p>
+            <a:r>
+              <a:t>DOCUMENTED (CrowdStrike RCA, 6 Aug 2024): the Content Validator validated Template Instances against the Template Type's 21 fields while the integration code supplied 20 (finding 4); Template Instances deployed to all endpoints with no staged rollout (finding 6); committed mitigations include canary deployment rings with rollback and customer control over Rapid Response Content deployment.</a:t>
+            </a:r>
+          </a:p>
+          <a:p>
+            <a:r>
+              <a:t>INTERPRETATION (ours, not the RCA's): the release organization's effective process model amounted to 'the Content Validator passed it, so it is safe to distribute' — and that model was wrong about what the validator actually checked. The RCA documents the validator defect; reading it as a controller's inaccurate process model is our STAMP-framed interpretation.</a:t>
+            </a:r>
+          </a:p>
+          <a:p>
+            <a:r>
+              <a:t>PROPOSED (instructional): the control structure drawn here is simplified. Do not claim every depicted feedback path existed or operated during the incident, and do not invent telemetry, approvals, or rollout stages the RCA does not document.</a:t>
             </a:r>
           </a:p>
           <a:p>
@@ -2599,12 +2624,17 @@
           </a:p>
           <a:p>
             <a:r>
-              <a:t>QUALIFICATION: this constraint is a CANDIDATE requirement for critical-service operators, not a documented universal obligation that existed before the outage.</a:t>
-            </a:r>
-          </a:p>
-          <a:p>
-            <a:r>
-              <a:t>FACTUAL BACKGROUND: CrowdStrike controls its software and content distribution. Customer organizations control aspects of deployment, continuity arrangements, and recovery. OS vendors control platform architecture. The responsibilities overlap but are not interchangeable: an enterprise cannot repair CrowdStrike's content-processing implementation; CrowdStrike cannot determine a hospital's continuity architecture.</a:t>
+              <a:t>DOCUMENTED: CrowdStrike controls its software and content distribution, and committed to giving customers control over Rapid Response Content deployment (RCA, 6 Aug 2024); affected organizations performed recovery across sectors (Microsoft, 20 Jul 2024). What any specific enterprise could or could not control is NOT documented in these sources.</a:t>
+            </a:r>
+          </a:p>
+          <a:p>
+            <a:r>
+              <a:t>INTERPRETATION (ours): the division of control drawn here — vendor release controls versus enterprise deployment and continuity controls — is a responsibility-allocation argument, not a finding of the postmortem. An enterprise cannot repair CrowdStrike's content-processing implementation; CrowdStrike cannot determine a hospital's continuity architecture.</a:t>
+            </a:r>
+          </a:p>
+          <a:p>
+            <a:r>
+              <a:t>PROPOSED (candidate requirement): the safety constraint itself. It is a candidate obligation for critical-service operators, not a documented universal obligation that existed before the outage.</a:t>
             </a:r>
           </a:p>
           <a:p>
@@ -2694,12 +2724,17 @@
           </a:p>
           <a:p>
             <a:r>
-              <a:t>ENGINEERING POINT: common-cause failure — multiple components or organizations fail together because they share a dependency, condition, or mechanism. Redundancy provides limited protection when the redundant elements share the same vulnerability: a thousand machines running the same privileged component are not a thousand independent defenses against that component's failure.</a:t>
-            </a:r>
-          </a:p>
-          <a:p>
-            <a:r>
-              <a:t>FACTUAL SAFEGUARDS: the outage establishes widespread correlated EXPOSURE to CrowdStrike's software. It does NOT establish that every affected organization relied exclusively on CrowdStrike for endpoint security. Keep vendor concentration, shared software dependencies, and absence of redundancy distinct — related but different properties. Scale stays qualified: ~8.5M devices, under 1% of Windows machines (Microsoft, 20 Jul 2024).</a:t>
+              <a:t>ENGINEERING POINT: common-cause failure — multiple components or organizations fail together because they share a dependency, condition, or mechanism. The caption states the principle exactly: replication does not provide independence when replicas share the same failure mode. A thousand machines running the same privileged component are not a thousand independent defenses against that component's failure. That is an engineering principle, NOT a claim about any particular organization's redundancy architecture.</a:t>
+            </a:r>
+          </a:p>
+          <a:p>
+            <a:r>
+              <a:t>DOCUMENTED: ~8.5 million Windows devices affected — under 1% of all Windows machines (Microsoft, 20 Jul 2024); one defective content update was the shared trigger (CrowdStrike RCA, 6 Aug 2024).</a:t>
+            </a:r>
+          </a:p>
+          <a:p>
+            <a:r>
+              <a:t>INTERPRETATION (ours): the simultaneous multi-sector disruption is explained by correlated exposure to a shared privileged dependency. The incident does NOT establish that affected organizations had redundancy, that redundancy failed, or that any organization relied exclusively on CrowdStrike for endpoint security. Keep vendor concentration, shared software dependencies, and absence of redundancy distinct — related but different properties.</a:t>
             </a:r>
           </a:p>
           <a:p>
@@ -2709,7 +2744,7 @@
           </a:p>
           <a:p>
             <a:r>
-              <a:t>EXPECTED ANSWERS: students name redundant SERVERS. Push to the sharper question: the issue is not how many machines an organization runs, but how independently its essential functions can continue when a shared dependency fails.</a:t>
+              <a:t>EXPECTED ANSWERS: students name redundant SERVERS. Push to the sharper question: not how many machines an organization runs, but how independently its essential functions can continue when a shared dependency fails.</a:t>
             </a:r>
           </a:p>
           <a:p>
@@ -2784,7 +2819,7 @@
           <a:lstStyle/>
           <a:p>
             <a:r>
-              <a:t>TIMING: 4 minutes. THE MAIN RISK SLIDE — do not let it become an argument for mandatory vendor diversity.</a:t>
+              <a:t>TIMING: 4 minutes — PROTECT the discussion: 'what independence should critical services actually require?' deserves the time (author pacing note). THE MAIN RISK SLIDE — do not let it become an argument for mandatory vendor diversity.</a:t>
             </a:r>
           </a:p>
           <a:p>
@@ -2794,12 +2829,17 @@
           </a:p>
           <a:p>
             <a:r>
-              <a:t>WHY VENDOR DIVERSITY IS NOT THE ANSWER KEY: two products may share an operating system, a cloud service, a configuration mechanism, or an administrative control plane — diversity of vendor names does not establish independence of failure modes. Conversely, an organization can obtain real resilience without a second endpoint product.</a:t>
-            </a:r>
-          </a:p>
-          <a:p>
-            <a:r>
-              <a:t>EPISTEMIC LADDER (keep it visible): OBSERVED — one vendor update produced widespread correlated failures. INFERRED — shared privileged dependencies created a common-cause vulnerability. PROPOSED — critical infrastructure might require more independence. UNRESOLVED — whether mandatory diversity would have helped, and whether its benefits justify its costs.</a:t>
+              <a:t>DOCUMENTED: one vendor update produced widespread correlated failures (CrowdStrike RCA, 6 Aug 2024; Microsoft, 20 Jul 2024).</a:t>
+            </a:r>
+          </a:p>
+          <a:p>
+            <a:r>
+              <a:t>INTERPRETATION (ours): shared privileged dependencies created a common-cause vulnerability across organizations.</a:t>
+            </a:r>
+          </a:p>
+          <a:p>
+            <a:r>
+              <a:t>PROPOSED — and explicitly UNRESOLVED: critical infrastructure might require more independence; whether mandatory vendor diversity would have prevented this incident, and whether its benefits justify its costs, is unresolved. Two products may share an operating system, a cloud service, a configuration mechanism, or an administrative control plane — diversity of vendor names does not establish independence of failure modes. Conversely, an organization can obtain real resilience without a second endpoint product.</a:t>
             </a:r>
           </a:p>
           <a:p>
@@ -2884,12 +2924,22 @@
           </a:p>
           <a:p>
             <a:r>
-              <a:t>ENGINEERING POINT: controllers exist above the vendor, and the causal account may extend beyond the authority of the engineer conducting the investigation. A vendor can repair its software and release controls. A critical-service operator can change procurement, deployment, and continuity requirements. A sector authority may be able to impose resilience obligations across organizations — where its legal mandate permits. A cause outside your authority still belongs in the account; the response is to identify the responsible controller and ESCALATE the proposed intervention, not to omit the cause.</a:t>
-            </a:r>
-          </a:p>
-          <a:p>
-            <a:r>
-              <a:t>CARE: the diagram is conceptual. Do not imply every sector has a regulator empowered to mandate the proposed controls, and do not slide from 'a failure analysis reveals a systemic risk' to 'regulation is necessary' — necessity, effectiveness, and proportionality are further engineering and policy judgments requiring evidence.</a:t>
+              <a:t>ENGINEERING POINT: controllers exist above the vendor, and each level pairs a control action with the feedback it needs — read the diagram as control AND feedback, not as a hierarchy of rank. STAMP without feedback is just an org chart. A cause outside your authority still belongs in the account; the response is to identify the responsible controller and ESCALATE the proposed intervention, not to omit the cause.</a:t>
+            </a:r>
+          </a:p>
+          <a:p>
+            <a:r>
+              <a:t>DOCUMENTED vs HYPOTHETICAL (the dashed edge): enterprise deployment and recovery controls, and operators' continuity policies, are ordinary existing arrangements of the kind the incident exercised. A sector authority imposing resilience requirements for endpoint-security failure is a HYPOTHETICAL addition to the control structure — drawn dashed. Not every sector has a regulator empowered to mandate such controls, and no source in this lecture documents one that did so for this incident.</a:t>
+            </a:r>
+          </a:p>
+          <a:p>
+            <a:r>
+              <a:t>INTERPRETATION (ours): reading the outage as evidence of a systemic risk that some controller should manage is our interpretation of the documented exposure, not a finding of the RCA.</a:t>
+            </a:r>
+          </a:p>
+          <a:p>
+            <a:r>
+              <a:t>PROPOSED: any specific obligation at any level of this diagram. A failure analysis may reveal a systemic risk without establishing that regulation is necessary, effective, or proportionate — those are further engineering and policy judgments requiring evidence.</a:t>
             </a:r>
           </a:p>
           <a:p>
@@ -2899,7 +2949,7 @@
           </a:p>
           <a:p>
             <a:r>
-              <a:t>EXPECTED ANSWERS: 'the government should require it.' Push back with the epistemic ladder from the last slide: proposed is not validated. Also surface the reverse misconception — 'if it's outside our authority it's out of scope.' Escalation is an engineering act.</a:t>
+              <a:t>EXPECTED ANSWERS: 'the government should require it.' Push back with the epistemic ladder: proposed is not validated. Also surface the reverse misconception — 'if it's outside our authority it's out of scope.' Escalation is an engineering act.</a:t>
             </a:r>
           </a:p>
           <a:p>
@@ -12557,7 +12607,7 @@
                   <a:srgbClr val="5C4826"/>
                 </a:solidFill>
               </a:rPr>
-              <a:t>Redundancy did not help — every replica shared the same dependency.</a:t>
+              <a:t>Replication does not provide independence when replicas share the same failure mode.</a:t>
             </a:r>
           </a:p>
         </p:txBody>
@@ -13575,6 +13625,7 @@
             <a:solidFill>
               <a:srgbClr val="8E6F3E"/>
             </a:solidFill>
+            <a:prstDash val="dash"/>
             <a:tailEnd type="triangle"/>
           </a:ln>
         </p:spPr>
@@ -13937,8 +13988,8 @@
         </p:nvSpPr>
         <p:spPr>
           <a:xfrm>
-            <a:off x="640080" y="2377440"/>
-            <a:ext cx="2103120" cy="731520"/>
+            <a:off x="502920" y="1737360"/>
+            <a:ext cx="2331720" cy="594360"/>
           </a:xfrm>
           <a:prstGeom prst="rect">
             <a:avLst/>
@@ -13953,23 +14004,23 @@
           <a:p>
             <a:pPr algn="r"/>
             <a:r>
-              <a:rPr sz="2000" b="0" i="0">
+              <a:rPr sz="1200" b="0" i="0">
                 <a:solidFill>
                   <a:srgbClr val="555960"/>
                 </a:solidFill>
               </a:rPr>
-              <a:t>requirements,</a:t>
+              <a:t>resilience requirements ↓</a:t>
             </a:r>
           </a:p>
           <a:p>
             <a:pPr algn="r"/>
             <a:r>
-              <a:rPr sz="2000" b="0" i="0">
+              <a:rPr sz="1200" b="0" i="0">
                 <a:solidFill>
                   <a:srgbClr val="555960"/>
                 </a:solidFill>
               </a:rPr>
-              <a:t>policies ↓</a:t>
+              <a:t>(hypothetical)</a:t>
             </a:r>
           </a:p>
         </p:txBody>
@@ -13982,8 +14033,8 @@
         </p:nvSpPr>
         <p:spPr>
           <a:xfrm>
-            <a:off x="6400800" y="2377440"/>
-            <a:ext cx="2194560" cy="731520"/>
+            <a:off x="6309360" y="1783080"/>
+            <a:ext cx="2651760" cy="365760"/>
           </a:xfrm>
           <a:prstGeom prst="rect">
             <a:avLst/>
@@ -13998,23 +14049,12 @@
           <a:p>
             <a:pPr algn="l"/>
             <a:r>
-              <a:rPr sz="2000" b="0" i="0">
+              <a:rPr sz="1200" b="0" i="0">
                 <a:solidFill>
                   <a:srgbClr val="555960"/>
                 </a:solidFill>
               </a:rPr>
-              <a:t>↑ reports, evidence,</a:t>
-            </a:r>
-          </a:p>
-          <a:p>
-            <a:pPr algn="l"/>
-            <a:r>
-              <a:rPr sz="2000" b="0" i="0">
-                <a:solidFill>
-                  <a:srgbClr val="555960"/>
-                </a:solidFill>
-              </a:rPr>
-              <a:t>operational feedback</a:t>
+              <a:t>↑ incident reports, evidence</a:t>
             </a:r>
           </a:p>
         </p:txBody>
@@ -14027,8 +14067,8 @@
         </p:nvSpPr>
         <p:spPr>
           <a:xfrm>
-            <a:off x="548640" y="5440680"/>
-            <a:ext cx="8046720" cy="347472"/>
+            <a:off x="548640" y="5212080"/>
+            <a:ext cx="8046720" cy="594360"/>
           </a:xfrm>
           <a:prstGeom prst="rect">
             <a:avLst/>
@@ -14043,12 +14083,23 @@
           <a:p>
             <a:pPr algn="ctr"/>
             <a:r>
-              <a:rPr sz="1400" b="0" i="0">
+              <a:rPr sz="1300" b="0" i="0">
                 <a:solidFill>
                   <a:srgbClr val="5C4826"/>
                 </a:solidFill>
               </a:rPr>
               <a:t>Not every sector has a regulator empowered to mandate these controls.</a:t>
+            </a:r>
+          </a:p>
+          <a:p>
+            <a:pPr algn="ctr"/>
+            <a:r>
+              <a:rPr sz="1300" b="0" i="0">
+                <a:solidFill>
+                  <a:srgbClr val="5C4826"/>
+                </a:solidFill>
+              </a:rPr>
+              <a:t>Dashed control = hypothetical addition to the structure, not a documented arrangement.</a:t>
             </a:r>
           </a:p>
         </p:txBody>
@@ -14101,6 +14152,142 @@
                 </a:solidFill>
               </a:rPr>
               <a:t>Which controller has the authority to enforce independence?</a:t>
+            </a:r>
+          </a:p>
+        </p:txBody>
+      </p:sp>
+      <p:sp>
+        <p:nvSpPr>
+          <p:cNvPr id="1001" name="Label"/>
+          <p:cNvSpPr txBox="1"/>
+          <p:nvPr/>
+        </p:nvSpPr>
+        <p:spPr>
+          <a:xfrm>
+            <a:off x="502920" y="2743200"/>
+            <a:ext cx="2331720" cy="548640"/>
+          </a:xfrm>
+          <a:prstGeom prst="rect">
+            <a:avLst/>
+          </a:prstGeom>
+          <a:noFill/>
+        </p:spPr>
+        <p:txBody>
+          <a:bodyPr wrap="square" lIns="27432" tIns="22860" rIns="27432" bIns="22860" anchor="t">
+            <a:spAutoFit/>
+          </a:bodyPr>
+          <a:lstStyle/>
+          <a:p>
+            <a:pPr algn="l"/>
+            <a:r>
+              <a:rPr sz="1200" b="0" i="0">
+                <a:solidFill>
+                  <a:srgbClr val="555960"/>
+                </a:solidFill>
+              </a:rPr>
+              <a:t>continuity policies ↓</a:t>
+            </a:r>
+          </a:p>
+        </p:txBody>
+      </p:sp>
+      <p:sp>
+        <p:nvSpPr>
+          <p:cNvPr id="1002" name="Label"/>
+          <p:cNvSpPr txBox="1"/>
+          <p:nvPr/>
+        </p:nvSpPr>
+        <p:spPr>
+          <a:xfrm>
+            <a:off x="502920" y="3675887"/>
+            <a:ext cx="2331720" cy="548640"/>
+          </a:xfrm>
+          <a:prstGeom prst="rect">
+            <a:avLst/>
+          </a:prstGeom>
+          <a:noFill/>
+        </p:spPr>
+        <p:txBody>
+          <a:bodyPr wrap="square" lIns="27432" tIns="22860" rIns="27432" bIns="22860" anchor="t">
+            <a:spAutoFit/>
+          </a:bodyPr>
+          <a:lstStyle/>
+          <a:p>
+            <a:pPr algn="l"/>
+            <a:r>
+              <a:rPr sz="1200" b="0" i="0">
+                <a:solidFill>
+                  <a:srgbClr val="555960"/>
+                </a:solidFill>
+              </a:rPr>
+              <a:t>deployment + recovery controls ↓</a:t>
+            </a:r>
+          </a:p>
+        </p:txBody>
+      </p:sp>
+      <p:sp>
+        <p:nvSpPr>
+          <p:cNvPr id="1003" name="Label"/>
+          <p:cNvSpPr txBox="1"/>
+          <p:nvPr/>
+        </p:nvSpPr>
+        <p:spPr>
+          <a:xfrm>
+            <a:off x="6309360" y="2788920"/>
+            <a:ext cx="2651760" cy="548640"/>
+          </a:xfrm>
+          <a:prstGeom prst="rect">
+            <a:avLst/>
+          </a:prstGeom>
+          <a:noFill/>
+        </p:spPr>
+        <p:txBody>
+          <a:bodyPr wrap="square" lIns="27432" tIns="22860" rIns="27432" bIns="22860" anchor="t">
+            <a:spAutoFit/>
+          </a:bodyPr>
+          <a:lstStyle/>
+          <a:p>
+            <a:pPr algn="l"/>
+            <a:r>
+              <a:rPr sz="1200" b="0" i="0">
+                <a:solidFill>
+                  <a:srgbClr val="555960"/>
+                </a:solidFill>
+              </a:rPr>
+              <a:t>↑ service availability</a:t>
+            </a:r>
+          </a:p>
+        </p:txBody>
+      </p:sp>
+      <p:sp>
+        <p:nvSpPr>
+          <p:cNvPr id="1004" name="Label"/>
+          <p:cNvSpPr txBox="1"/>
+          <p:nvPr/>
+        </p:nvSpPr>
+        <p:spPr>
+          <a:xfrm>
+            <a:off x="6309360" y="3721608"/>
+            <a:ext cx="2651760" cy="548640"/>
+          </a:xfrm>
+          <a:prstGeom prst="rect">
+            <a:avLst/>
+          </a:prstGeom>
+          <a:noFill/>
+        </p:spPr>
+        <p:txBody>
+          <a:bodyPr wrap="square" lIns="27432" tIns="22860" rIns="27432" bIns="22860" anchor="t">
+            <a:spAutoFit/>
+          </a:bodyPr>
+          <a:lstStyle/>
+          <a:p>
+            <a:pPr algn="l"/>
+            <a:r>
+              <a:rPr sz="1200" b="0" i="0">
+                <a:solidFill>
+                  <a:srgbClr val="555960"/>
+                </a:solidFill>
+              </a:rPr>
+              <a:t>↑ operational evidence, telemetry</a:t>
             </a:r>
           </a:p>
         </p:txBody>
@@ -15239,7 +15426,7 @@
                   <a:srgbClr val="5C4826"/>
                 </a:solidFill>
               </a:rPr>
-              <a:t>Broader explanations require more evidence and more authority to act on.</a:t>
+              <a:t>Broader explanations require more evidence and may require greater authority to act.</a:t>
             </a:r>
           </a:p>
           <a:p>
@@ -16072,7 +16259,7 @@
                   <a:srgbClr val="5C4826"/>
                 </a:solidFill>
               </a:rPr>
-              <a:t>consequence</a:t>
+              <a:t>CONSEQUENCE</a:t>
             </a:r>
             <a:endParaRPr sz="2000" b="0" i="1" dirty="0">
               <a:solidFill>
@@ -16255,7 +16442,7 @@
                   <a:srgbClr val="5C4826"/>
                 </a:solidFill>
               </a:rPr>
-              <a:t>repertoire</a:t>
+              <a:t>REPERTOIRE</a:t>
             </a:r>
           </a:p>
         </p:txBody>
@@ -19312,6 +19499,212 @@
           </a:p>
         </p:txBody>
       </p:sp>
+      <p:sp>
+        <p:nvSpPr>
+          <p:cNvPr id="915" name="Label"/>
+          <p:cNvSpPr txBox="1"/>
+          <p:nvPr/>
+        </p:nvSpPr>
+        <p:spPr>
+          <a:xfrm>
+            <a:off x="548640" y="4599432"/>
+            <a:ext cx="2560320" cy="274320"/>
+          </a:xfrm>
+          <a:prstGeom prst="rect">
+            <a:avLst/>
+          </a:prstGeom>
+          <a:noFill/>
+        </p:spPr>
+        <p:txBody>
+          <a:bodyPr wrap="square" lIns="27432" tIns="22860" rIns="27432" bIns="22860" anchor="t">
+            <a:spAutoFit/>
+          </a:bodyPr>
+          <a:lstStyle/>
+          <a:p>
+            <a:pPr algn="ctr"/>
+            <a:r>
+              <a:rPr sz="1200" b="1" i="0">
+                <a:solidFill>
+                  <a:srgbClr val="5C4826"/>
+                </a:solidFill>
+              </a:rPr>
+              <a:t>‘x=x’  →  23 steps</a:t>
+            </a:r>
+          </a:p>
+        </p:txBody>
+      </p:sp>
+      <p:sp>
+        <p:nvSpPr>
+          <p:cNvPr id="910" name="Block"/>
+          <p:cNvSpPr/>
+          <p:nvPr/>
+        </p:nvSpPr>
+        <p:spPr>
+          <a:xfrm>
+            <a:off x="3291840" y="4626864"/>
+            <a:ext cx="237744" cy="182880"/>
+          </a:xfrm>
+          <a:prstGeom prst="rect">
+            <a:avLst/>
+          </a:prstGeom>
+          <a:solidFill>
+            <a:srgbClr val="8E6F3E"/>
+          </a:solidFill>
+          <a:ln>
+            <a:noFill/>
+          </a:ln>
+          <a:effectLst/>
+        </p:spPr>
+        <p:style>
+          <a:lnRef idx="1">
+            <a:schemeClr val="accent1"/>
+          </a:lnRef>
+          <a:fillRef idx="3">
+            <a:schemeClr val="accent1"/>
+          </a:fillRef>
+          <a:effectRef idx="2">
+            <a:schemeClr val="accent1"/>
+          </a:effectRef>
+          <a:fontRef idx="minor">
+            <a:schemeClr val="lt1"/>
+          </a:fontRef>
+        </p:style>
+        <p:txBody>
+          <a:bodyPr wrap="square" lIns="27432" tIns="22860" rIns="27432" bIns="22860" rtlCol="0" anchor="ctr"/>
+          <a:lstStyle/>
+          <a:p>
+            <a:pPr algn="ctr"/>
+            <a:r>
+              <a:rPr sz="1200" b="1" i="0">
+                <a:solidFill>
+                  <a:srgbClr val="FFFFFF"/>
+                </a:solidFill>
+              </a:rPr>
+              <a:t/>
+            </a:r>
+          </a:p>
+        </p:txBody>
+      </p:sp>
+      <p:sp>
+        <p:nvSpPr>
+          <p:cNvPr id="1000" name="Label"/>
+          <p:cNvSpPr txBox="1"/>
+          <p:nvPr/>
+        </p:nvSpPr>
+        <p:spPr>
+          <a:xfrm>
+            <a:off x="548640" y="4919472"/>
+            <a:ext cx="2560320" cy="274320"/>
+          </a:xfrm>
+          <a:prstGeom prst="rect">
+            <a:avLst/>
+          </a:prstGeom>
+          <a:noFill/>
+        </p:spPr>
+        <p:txBody>
+          <a:bodyPr wrap="square" lIns="27432" tIns="22860" rIns="27432" bIns="22860" anchor="t">
+            <a:spAutoFit/>
+          </a:bodyPr>
+          <a:lstStyle/>
+          <a:p>
+            <a:pPr algn="ctr"/>
+            <a:r>
+              <a:rPr sz="1200" b="1" i="0">
+                <a:solidFill>
+                  <a:srgbClr val="5C4826"/>
+                </a:solidFill>
+              </a:rPr>
+              <a:t>‘x=’ + twenty ‘x’s  →  555 steps</a:t>
+            </a:r>
+          </a:p>
+        </p:txBody>
+      </p:sp>
+      <p:sp>
+        <p:nvSpPr>
+          <p:cNvPr id="1001" name="Block"/>
+          <p:cNvSpPr/>
+          <p:nvPr/>
+        </p:nvSpPr>
+        <p:spPr>
+          <a:xfrm>
+            <a:off x="3291840" y="4946904"/>
+            <a:ext cx="5486400" cy="182880"/>
+          </a:xfrm>
+          <a:prstGeom prst="rect">
+            <a:avLst/>
+          </a:prstGeom>
+          <a:solidFill>
+            <a:srgbClr val="B3261E"/>
+          </a:solidFill>
+          <a:ln>
+            <a:noFill/>
+          </a:ln>
+          <a:effectLst/>
+        </p:spPr>
+        <p:style>
+          <a:lnRef idx="1">
+            <a:schemeClr val="accent1"/>
+          </a:lnRef>
+          <a:fillRef idx="3">
+            <a:schemeClr val="accent1"/>
+          </a:fillRef>
+          <a:effectRef idx="2">
+            <a:schemeClr val="accent1"/>
+          </a:effectRef>
+          <a:fontRef idx="minor">
+            <a:schemeClr val="lt1"/>
+          </a:fontRef>
+        </p:style>
+        <p:txBody>
+          <a:bodyPr wrap="square" lIns="27432" tIns="22860" rIns="27432" bIns="22860" rtlCol="0" anchor="ctr"/>
+          <a:lstStyle/>
+          <a:p>
+            <a:pPr algn="ctr"/>
+            <a:r>
+              <a:rPr sz="1200" b="1" i="0">
+                <a:solidFill>
+                  <a:srgbClr val="FFFFFF"/>
+                </a:solidFill>
+              </a:rPr>
+              <a:t/>
+            </a:r>
+          </a:p>
+        </p:txBody>
+      </p:sp>
+      <p:sp>
+        <p:nvSpPr>
+          <p:cNvPr id="1002" name="Label"/>
+          <p:cNvSpPr txBox="1"/>
+          <p:nvPr/>
+        </p:nvSpPr>
+        <p:spPr>
+          <a:xfrm>
+            <a:off x="3291840" y="5193792"/>
+            <a:ext cx="5120640" cy="256032"/>
+          </a:xfrm>
+          <a:prstGeom prst="rect">
+            <a:avLst/>
+          </a:prstGeom>
+          <a:noFill/>
+        </p:spPr>
+        <p:txBody>
+          <a:bodyPr wrap="square" lIns="27432" tIns="22860" rIns="27432" bIns="22860" anchor="t">
+            <a:spAutoFit/>
+          </a:bodyPr>
+          <a:lstStyle/>
+          <a:p>
+            <a:pPr algn="ctr"/>
+            <a:r>
+              <a:rPr sz="1000" b="1" i="0">
+                <a:solidFill>
+                  <a:srgbClr val="5C4826"/>
+                </a:solidFill>
+              </a:rPr>
+              <a:t>the same rule — the input grew from 3 to 22 characters</a:t>
+            </a:r>
+          </a:p>
+        </p:txBody>
+      </p:sp>
     </p:spTree>
   </p:cSld>
   <p:clrMapOvr>
@@ -20218,8 +20611,8 @@
         </p:nvSpPr>
         <p:spPr>
           <a:xfrm>
-            <a:off x="1188720" y="4160520"/>
-            <a:ext cx="2560320" cy="777240"/>
+            <a:off x="1005840" y="4160520"/>
+            <a:ext cx="2926080" cy="777240"/>
           </a:xfrm>
           <a:prstGeom prst="rect">
             <a:avLst/>
@@ -20252,7 +20645,7 @@
           <a:p>
             <a:pPr algn="ctr"/>
             <a:r>
-              <a:rPr sz="2000" b="1" i="0">
+              <a:rPr sz="1300" b="1" i="0">
                 <a:solidFill>
                   <a:srgbClr val="FFFFFF"/>
                 </a:solidFill>
@@ -20281,8 +20674,8 @@
         </p:nvSpPr>
         <p:spPr>
           <a:xfrm>
-            <a:off x="5394960" y="4160520"/>
-            <a:ext cx="2560320" cy="777240"/>
+            <a:off x="5212080" y="4160520"/>
+            <a:ext cx="2926080" cy="777240"/>
           </a:xfrm>
           <a:prstGeom prst="rect">
             <a:avLst/>
@@ -20315,7 +20708,7 @@
           <a:p>
             <a:pPr algn="ctr"/>
             <a:r>
-              <a:rPr sz="2000" b="1" i="0">
+              <a:rPr sz="1300" b="1" i="0">
                 <a:solidFill>
                   <a:srgbClr val="FFFFFF"/>
                 </a:solidFill>
@@ -20344,8 +20737,8 @@
         </p:nvSpPr>
         <p:spPr>
           <a:xfrm>
-            <a:off x="1188720" y="5303520"/>
-            <a:ext cx="2560320" cy="502920"/>
+            <a:off x="1005840" y="5303520"/>
+            <a:ext cx="2926080" cy="502920"/>
           </a:xfrm>
           <a:prstGeom prst="rect">
             <a:avLst/>
@@ -20403,8 +20796,8 @@
         </p:nvSpPr>
         <p:spPr>
           <a:xfrm>
-            <a:off x="5394960" y="5303520"/>
-            <a:ext cx="2560320" cy="502920"/>
+            <a:off x="5212080" y="5303520"/>
+            <a:ext cx="2926080" cy="502920"/>
           </a:xfrm>
           <a:prstGeom prst="rect">
             <a:avLst/>
@@ -21175,14 +21568,14 @@
       </p:sp>
       <p:sp>
         <p:nvSpPr>
-          <p:cNvPr id="920" name="Block"/>
+          <p:cNvPr id="910" name="Block"/>
           <p:cNvSpPr/>
           <p:nvPr/>
         </p:nvSpPr>
         <p:spPr>
           <a:xfrm>
-            <a:off x="548640" y="1143000"/>
-            <a:ext cx="2560320" cy="566928"/>
+            <a:off x="2743200" y="1005840"/>
+            <a:ext cx="3657600" cy="502920"/>
           </a:xfrm>
           <a:prstGeom prst="rect">
             <a:avLst/>
@@ -21220,28 +21613,32 @@
                   <a:srgbClr val="FFFFFF"/>
                 </a:solidFill>
               </a:rPr>
-              <a:t>TEMPLATE TYPE</a:t>
-            </a:r>
-          </a:p>
-        </p:txBody>
-      </p:sp>
-      <p:sp>
-        <p:nvSpPr>
-          <p:cNvPr id="921" name="RowCaption"/>
+              <a:t>TEMPLATE DEFINITION: 21 FIELDS</a:t>
+            </a:r>
+          </a:p>
+        </p:txBody>
+      </p:sp>
+      <p:sp>
+        <p:nvSpPr>
+          <p:cNvPr id="912" name="Card"/>
           <p:cNvSpPr/>
           <p:nvPr/>
         </p:nvSpPr>
         <p:spPr>
           <a:xfrm>
-            <a:off x="3383280" y="1143000"/>
-            <a:ext cx="5212080" cy="566928"/>
-          </a:xfrm>
-          <a:prstGeom prst="rect">
-            <a:avLst/>
-          </a:prstGeom>
-          <a:noFill/>
-          <a:ln>
-            <a:noFill/>
+            <a:off x="822960" y="1965960"/>
+            <a:ext cx="3291840" cy="502920"/>
+          </a:xfrm>
+          <a:prstGeom prst="rect">
+            <a:avLst/>
+          </a:prstGeom>
+          <a:solidFill>
+            <a:srgbClr val="F5F1E8"/>
+          </a:solidFill>
+          <a:ln w="12700">
+            <a:solidFill>
+              <a:srgbClr val="C9B991"/>
+            </a:solidFill>
           </a:ln>
           <a:effectLst/>
         </p:spPr>
@@ -21263,33 +21660,87 @@
           <a:bodyPr wrap="square" lIns="27432" tIns="22860" rIns="27432" bIns="22860" rtlCol="0" anchor="ctr"/>
           <a:lstStyle/>
           <a:p>
-            <a:pPr algn="l"/>
-            <a:r>
-              <a:rPr sz="2000" b="0" i="0">
-                <a:solidFill>
-                  <a:srgbClr val="555960"/>
-                </a:solidFill>
-              </a:rPr>
-              <a:t>defined 21 input parameter fields</a:t>
+            <a:pPr algn="ctr"/>
+            <a:r>
+              <a:rPr sz="2000" b="1" i="0">
+                <a:solidFill>
+                  <a:srgbClr val="5C4826"/>
+                </a:solidFill>
+              </a:rPr>
+              <a:t>content expects 21 inputs</a:t>
+            </a:r>
+          </a:p>
+        </p:txBody>
+      </p:sp>
+      <p:sp>
+        <p:nvSpPr>
+          <p:cNvPr id="1000" name="Card"/>
+          <p:cNvSpPr/>
+          <p:nvPr/>
+        </p:nvSpPr>
+        <p:spPr>
+          <a:xfrm>
+            <a:off x="5029200" y="1965960"/>
+            <a:ext cx="3291840" cy="502920"/>
+          </a:xfrm>
+          <a:prstGeom prst="rect">
+            <a:avLst/>
+          </a:prstGeom>
+          <a:solidFill>
+            <a:srgbClr val="F5F1E8"/>
+          </a:solidFill>
+          <a:ln w="12700">
+            <a:solidFill>
+              <a:srgbClr val="C9B991"/>
+            </a:solidFill>
+          </a:ln>
+          <a:effectLst/>
+        </p:spPr>
+        <p:style>
+          <a:lnRef idx="1">
+            <a:schemeClr val="accent1"/>
+          </a:lnRef>
+          <a:fillRef idx="3">
+            <a:schemeClr val="accent1"/>
+          </a:fillRef>
+          <a:effectRef idx="2">
+            <a:schemeClr val="accent1"/>
+          </a:effectRef>
+          <a:fontRef idx="minor">
+            <a:schemeClr val="lt1"/>
+          </a:fontRef>
+        </p:style>
+        <p:txBody>
+          <a:bodyPr wrap="square" lIns="27432" tIns="22860" rIns="27432" bIns="22860" rtlCol="0" anchor="ctr"/>
+          <a:lstStyle/>
+          <a:p>
+            <a:pPr algn="ctr"/>
+            <a:r>
+              <a:rPr sz="2000" b="1" i="0">
+                <a:solidFill>
+                  <a:srgbClr val="5C4826"/>
+                </a:solidFill>
+              </a:rPr>
+              <a:t>integration code supplies 20</a:t>
             </a:r>
           </a:p>
         </p:txBody>
       </p:sp>
       <p:cxnSp>
         <p:nvCxnSpPr>
-          <p:cNvPr id="922" name="Connector 922"/>
+          <p:cNvPr id="911" name="Connector 911"/>
           <p:cNvCxnSpPr/>
           <p:nvPr/>
         </p:nvCxnSpPr>
         <p:spPr>
-          <a:xfrm>
-            <a:off x="1828800" y="1709928"/>
-            <a:ext cx="0" cy="393192"/>
+          <a:xfrm flipH="1">
+            <a:off x="2468880" y="1508760"/>
+            <a:ext cx="1554480" cy="457200"/>
           </a:xfrm>
           <a:prstGeom prst="line">
             <a:avLst/>
           </a:prstGeom>
-          <a:ln w="19050">
+          <a:ln w="28575">
             <a:solidFill>
               <a:srgbClr val="8E6F3E"/>
             </a:solidFill>
@@ -21311,16 +21762,52 @@
           </a:fontRef>
         </p:style>
       </p:cxnSp>
-      <p:sp>
-        <p:nvSpPr>
-          <p:cNvPr id="923" name="Block"/>
+      <p:cxnSp>
+        <p:nvCxnSpPr>
+          <p:cNvPr id="1001" name="Connector 911"/>
+          <p:cNvCxnSpPr/>
+          <p:nvPr/>
+        </p:nvCxnSpPr>
+        <p:spPr>
+          <a:xfrm>
+            <a:off x="5120640" y="1508760"/>
+            <a:ext cx="1554480" cy="457200"/>
+          </a:xfrm>
+          <a:prstGeom prst="line">
+            <a:avLst/>
+          </a:prstGeom>
+          <a:ln w="28575">
+            <a:solidFill>
+              <a:srgbClr val="8E6F3E"/>
+            </a:solidFill>
+            <a:tailEnd type="triangle"/>
+          </a:ln>
+        </p:spPr>
+        <p:style>
+          <a:lnRef idx="2">
+            <a:schemeClr val="accent1"/>
+          </a:lnRef>
+          <a:fillRef idx="0">
+            <a:schemeClr val="accent1"/>
+          </a:fillRef>
+          <a:effectRef idx="1">
+            <a:schemeClr val="accent1"/>
+          </a:effectRef>
+          <a:fontRef idx="minor">
+            <a:schemeClr val="tx1"/>
+          </a:fontRef>
+        </p:style>
+      </p:cxnSp>
+      <p:sp>
+        <p:nvSpPr>
+          <p:cNvPr id="1002" name="Block"/>
           <p:cNvSpPr/>
           <p:nvPr/>
         </p:nvSpPr>
         <p:spPr>
           <a:xfrm>
-            <a:off x="548640" y="2103120"/>
-            <a:ext cx="2560320" cy="566928"/>
+            <a:off x="3108960" y="2971800"/>
+            <a:ext cx="2926080" cy="502920"/>
           </a:xfrm>
           <a:prstGeom prst="rect">
             <a:avLst/>
@@ -21358,76 +21845,26 @@
                   <a:srgbClr val="FFFFFF"/>
                 </a:solidFill>
               </a:rPr>
-              <a:t>INTEGRATION CODE</a:t>
-            </a:r>
-          </a:p>
-        </p:txBody>
-      </p:sp>
-      <p:sp>
-        <p:nvSpPr>
-          <p:cNvPr id="924" name="RowCaption"/>
-          <p:cNvSpPr/>
-          <p:nvPr/>
-        </p:nvSpPr>
-        <p:spPr>
-          <a:xfrm>
-            <a:off x="3383280" y="2103120"/>
-            <a:ext cx="5212080" cy="566928"/>
-          </a:xfrm>
-          <a:prstGeom prst="rect">
-            <a:avLst/>
-          </a:prstGeom>
-          <a:noFill/>
-          <a:ln>
-            <a:noFill/>
-          </a:ln>
-          <a:effectLst/>
-        </p:spPr>
-        <p:style>
-          <a:lnRef idx="1">
-            <a:schemeClr val="accent1"/>
-          </a:lnRef>
-          <a:fillRef idx="3">
-            <a:schemeClr val="accent1"/>
-          </a:fillRef>
-          <a:effectRef idx="2">
-            <a:schemeClr val="accent1"/>
-          </a:effectRef>
-          <a:fontRef idx="minor">
-            <a:schemeClr val="lt1"/>
-          </a:fontRef>
-        </p:style>
-        <p:txBody>
-          <a:bodyPr wrap="square" lIns="27432" tIns="22860" rIns="27432" bIns="22860" rtlCol="0" anchor="ctr"/>
-          <a:lstStyle/>
-          <a:p>
-            <a:pPr algn="l"/>
-            <a:r>
-              <a:rPr sz="2000" b="0" i="0">
-                <a:solidFill>
-                  <a:srgbClr val="555960"/>
-                </a:solidFill>
-              </a:rPr>
-              <a:t>supplied only 20 input values to match against</a:t>
+              <a:t>INPUT ARRAY [0 … 19]</a:t>
             </a:r>
           </a:p>
         </p:txBody>
       </p:sp>
       <p:cxnSp>
         <p:nvCxnSpPr>
-          <p:cNvPr id="925" name="Connector 925"/>
+          <p:cNvPr id="1003" name="Connector 911"/>
           <p:cNvCxnSpPr/>
           <p:nvPr/>
         </p:nvCxnSpPr>
         <p:spPr>
           <a:xfrm>
-            <a:off x="1828800" y="2670048"/>
-            <a:ext cx="0" cy="393192"/>
+            <a:off x="2468880" y="2468880"/>
+            <a:ext cx="1371600" cy="502919"/>
           </a:xfrm>
           <a:prstGeom prst="line">
             <a:avLst/>
           </a:prstGeom>
-          <a:ln w="19050">
+          <a:ln w="28575">
             <a:solidFill>
               <a:srgbClr val="8E6F3E"/>
             </a:solidFill>
@@ -21449,123 +21886,21 @@
           </a:fontRef>
         </p:style>
       </p:cxnSp>
-      <p:sp>
-        <p:nvSpPr>
-          <p:cNvPr id="926" name="Block"/>
-          <p:cNvSpPr/>
-          <p:nvPr/>
-        </p:nvSpPr>
-        <p:spPr>
-          <a:xfrm>
-            <a:off x="548640" y="3063240"/>
-            <a:ext cx="2560320" cy="566928"/>
-          </a:xfrm>
-          <a:prstGeom prst="rect">
-            <a:avLst/>
-          </a:prstGeom>
-          <a:solidFill>
-            <a:srgbClr val="8E6F3E"/>
-          </a:solidFill>
-          <a:ln>
-            <a:noFill/>
-          </a:ln>
-          <a:effectLst/>
-        </p:spPr>
-        <p:style>
-          <a:lnRef idx="1">
-            <a:schemeClr val="accent1"/>
-          </a:lnRef>
-          <a:fillRef idx="3">
-            <a:schemeClr val="accent1"/>
-          </a:fillRef>
-          <a:effectRef idx="2">
-            <a:schemeClr val="accent1"/>
-          </a:effectRef>
-          <a:fontRef idx="minor">
-            <a:schemeClr val="lt1"/>
-          </a:fontRef>
-        </p:style>
-        <p:txBody>
-          <a:bodyPr wrap="square" lIns="27432" tIns="22860" rIns="27432" bIns="22860" rtlCol="0" anchor="ctr"/>
-          <a:lstStyle/>
-          <a:p>
-            <a:pPr algn="ctr"/>
-            <a:r>
-              <a:rPr sz="2000" b="1" i="0" dirty="0">
-                <a:solidFill>
-                  <a:srgbClr val="FFFFFF"/>
-                </a:solidFill>
-              </a:rPr>
-              <a:t>CONTENT VALIDATOR</a:t>
-            </a:r>
-          </a:p>
-        </p:txBody>
-      </p:sp>
-      <p:sp>
-        <p:nvSpPr>
-          <p:cNvPr id="927" name="RowCaption"/>
-          <p:cNvSpPr/>
-          <p:nvPr/>
-        </p:nvSpPr>
-        <p:spPr>
-          <a:xfrm>
-            <a:off x="3383280" y="3063240"/>
-            <a:ext cx="5212080" cy="566928"/>
-          </a:xfrm>
-          <a:prstGeom prst="rect">
-            <a:avLst/>
-          </a:prstGeom>
-          <a:noFill/>
-          <a:ln>
-            <a:noFill/>
-          </a:ln>
-          <a:effectLst/>
-        </p:spPr>
-        <p:style>
-          <a:lnRef idx="1">
-            <a:schemeClr val="accent1"/>
-          </a:lnRef>
-          <a:fillRef idx="3">
-            <a:schemeClr val="accent1"/>
-          </a:fillRef>
-          <a:effectRef idx="2">
-            <a:schemeClr val="accent1"/>
-          </a:effectRef>
-          <a:fontRef idx="minor">
-            <a:schemeClr val="lt1"/>
-          </a:fontRef>
-        </p:style>
-        <p:txBody>
-          <a:bodyPr wrap="square" lIns="27432" tIns="22860" rIns="27432" bIns="22860" rtlCol="0" anchor="ctr"/>
-          <a:lstStyle/>
-          <a:p>
-            <a:pPr algn="l"/>
-            <a:r>
-              <a:rPr sz="2000" b="0" i="0">
-                <a:solidFill>
-                  <a:srgbClr val="555960"/>
-                </a:solidFill>
-              </a:rPr>
-              <a:t>accepted instances that expected 21 inputs</a:t>
-            </a:r>
-          </a:p>
-        </p:txBody>
-      </p:sp>
       <p:cxnSp>
         <p:nvCxnSpPr>
-          <p:cNvPr id="928" name="Connector 928"/>
+          <p:cNvPr id="1004" name="Connector 911"/>
           <p:cNvCxnSpPr/>
           <p:nvPr/>
         </p:nvCxnSpPr>
         <p:spPr>
-          <a:xfrm>
-            <a:off x="1828800" y="3630168"/>
-            <a:ext cx="0" cy="393192"/>
+          <a:xfrm flipH="1">
+            <a:off x="5303520" y="2468880"/>
+            <a:ext cx="1371600" cy="502919"/>
           </a:xfrm>
           <a:prstGeom prst="line">
             <a:avLst/>
           </a:prstGeom>
-          <a:ln w="19050">
+          <a:ln w="28575">
             <a:solidFill>
               <a:srgbClr val="8E6F3E"/>
             </a:solidFill>
@@ -21589,23 +21924,25 @@
       </p:cxnSp>
       <p:sp>
         <p:nvSpPr>
-          <p:cNvPr id="929" name="Block"/>
+          <p:cNvPr id="1005" name="Card"/>
           <p:cNvSpPr/>
           <p:nvPr/>
         </p:nvSpPr>
         <p:spPr>
           <a:xfrm>
-            <a:off x="548640" y="4023360"/>
-            <a:ext cx="2560320" cy="566928"/>
+            <a:off x="2926080" y="3931920"/>
+            <a:ext cx="3291840" cy="502920"/>
           </a:xfrm>
           <a:prstGeom prst="rect">
             <a:avLst/>
           </a:prstGeom>
           <a:solidFill>
-            <a:srgbClr val="9A3F12"/>
+            <a:srgbClr val="F5F1E8"/>
           </a:solidFill>
-          <a:ln>
-            <a:noFill/>
+          <a:ln w="12700">
+            <a:solidFill>
+              <a:srgbClr val="C9B991"/>
+            </a:solidFill>
           </a:ln>
           <a:effectLst/>
         </p:spPr>
@@ -21631,69 +21968,140 @@
             <a:r>
               <a:rPr sz="2000" b="1" i="0">
                 <a:solidFill>
+                  <a:srgbClr val="5C4826"/>
+                </a:solidFill>
+              </a:rPr>
+              <a:t>interpreter attempts access [20]</a:t>
+            </a:r>
+          </a:p>
+        </p:txBody>
+      </p:sp>
+      <p:cxnSp>
+        <p:nvCxnSpPr>
+          <p:cNvPr id="1006" name="Connector 911"/>
+          <p:cNvCxnSpPr/>
+          <p:nvPr/>
+        </p:nvCxnSpPr>
+        <p:spPr>
+          <a:xfrm>
+            <a:off x="4572000" y="3474720"/>
+            <a:ext cx="0" cy="457200"/>
+          </a:xfrm>
+          <a:prstGeom prst="line">
+            <a:avLst/>
+          </a:prstGeom>
+          <a:ln w="28575">
+            <a:solidFill>
+              <a:srgbClr val="8E6F3E"/>
+            </a:solidFill>
+            <a:tailEnd type="triangle"/>
+          </a:ln>
+        </p:spPr>
+        <p:style>
+          <a:lnRef idx="2">
+            <a:schemeClr val="accent1"/>
+          </a:lnRef>
+          <a:fillRef idx="0">
+            <a:schemeClr val="accent1"/>
+          </a:fillRef>
+          <a:effectRef idx="1">
+            <a:schemeClr val="accent1"/>
+          </a:effectRef>
+          <a:fontRef idx="minor">
+            <a:schemeClr val="tx1"/>
+          </a:fontRef>
+        </p:style>
+      </p:cxnSp>
+      <p:sp>
+        <p:nvSpPr>
+          <p:cNvPr id="1007" name="Block"/>
+          <p:cNvSpPr/>
+          <p:nvPr/>
+        </p:nvSpPr>
+        <p:spPr>
+          <a:xfrm>
+            <a:off x="3200400" y="4846320"/>
+            <a:ext cx="2743200" cy="502920"/>
+          </a:xfrm>
+          <a:prstGeom prst="rect">
+            <a:avLst/>
+          </a:prstGeom>
+          <a:solidFill>
+            <a:srgbClr val="8E6F3E"/>
+          </a:solidFill>
+          <a:ln w="25400">
+            <a:solidFill>
+              <a:srgbClr val="B3261E"/>
+            </a:solidFill>
+          </a:ln>
+          <a:effectLst/>
+        </p:spPr>
+        <p:style>
+          <a:lnRef idx="1">
+            <a:schemeClr val="accent1"/>
+          </a:lnRef>
+          <a:fillRef idx="3">
+            <a:schemeClr val="accent1"/>
+          </a:fillRef>
+          <a:effectRef idx="2">
+            <a:schemeClr val="accent1"/>
+          </a:effectRef>
+          <a:fontRef idx="minor">
+            <a:schemeClr val="lt1"/>
+          </a:fontRef>
+        </p:style>
+        <p:txBody>
+          <a:bodyPr wrap="square" lIns="27432" tIns="22860" rIns="27432" bIns="22860" rtlCol="0" anchor="ctr"/>
+          <a:lstStyle/>
+          <a:p>
+            <a:pPr algn="ctr"/>
+            <a:r>
+              <a:rPr sz="2000" b="1" i="0">
+                <a:solidFill>
                   <a:srgbClr val="FFFFFF"/>
                 </a:solidFill>
               </a:rPr>
-              <a:t>CONTENT INTERPRETER</a:t>
-            </a:r>
-          </a:p>
-        </p:txBody>
-      </p:sp>
-      <p:sp>
-        <p:nvSpPr>
-          <p:cNvPr id="930" name="RowCaption"/>
-          <p:cNvSpPr/>
-          <p:nvPr/>
-        </p:nvSpPr>
-        <p:spPr>
-          <a:xfrm>
-            <a:off x="3383280" y="4023360"/>
-            <a:ext cx="5212080" cy="566928"/>
-          </a:xfrm>
-          <a:prstGeom prst="rect">
-            <a:avLst/>
-          </a:prstGeom>
-          <a:noFill/>
-          <a:ln>
-            <a:noFill/>
-          </a:ln>
-          <a:effectLst/>
-        </p:spPr>
-        <p:style>
-          <a:lnRef idx="1">
-            <a:schemeClr val="accent1"/>
-          </a:lnRef>
-          <a:fillRef idx="3">
-            <a:schemeClr val="accent1"/>
-          </a:fillRef>
-          <a:effectRef idx="2">
-            <a:schemeClr val="accent1"/>
-          </a:effectRef>
-          <a:fontRef idx="minor">
-            <a:schemeClr val="lt1"/>
-          </a:fontRef>
-        </p:style>
-        <p:txBody>
-          <a:bodyPr wrap="square" lIns="27432" tIns="22860" rIns="27432" bIns="22860" rtlCol="0" anchor="ctr"/>
-          <a:lstStyle/>
-          <a:p>
-            <a:pPr algn="l"/>
-            <a:r>
-              <a:rPr sz="2000" b="1" i="0" dirty="0">
-                <a:solidFill>
-                  <a:srgbClr val="555960"/>
-                </a:solidFill>
-              </a:rPr>
-              <a:t>expected 20 — and read the 21st entry</a:t>
-            </a:r>
-            <a:endParaRPr sz="2000" b="1" i="0" dirty="0">
-              <a:solidFill>
-                <a:srgbClr val="555960"/>
-              </a:solidFill>
-            </a:endParaRPr>
-          </a:p>
-        </p:txBody>
-      </p:sp>
+              <a:t>OUT-OF-BOUNDS READ</a:t>
+            </a:r>
+          </a:p>
+        </p:txBody>
+      </p:sp>
+      <p:cxnSp>
+        <p:nvCxnSpPr>
+          <p:cNvPr id="1008" name="Connector 911"/>
+          <p:cNvCxnSpPr/>
+          <p:nvPr/>
+        </p:nvCxnSpPr>
+        <p:spPr>
+          <a:xfrm>
+            <a:off x="4572000" y="4434840"/>
+            <a:ext cx="0" cy="411480"/>
+          </a:xfrm>
+          <a:prstGeom prst="line">
+            <a:avLst/>
+          </a:prstGeom>
+          <a:ln w="28575">
+            <a:solidFill>
+              <a:srgbClr val="8E6F3E"/>
+            </a:solidFill>
+            <a:tailEnd type="triangle"/>
+          </a:ln>
+        </p:spPr>
+        <p:style>
+          <a:lnRef idx="2">
+            <a:schemeClr val="accent1"/>
+          </a:lnRef>
+          <a:fillRef idx="0">
+            <a:schemeClr val="accent1"/>
+          </a:fillRef>
+          <a:effectRef idx="1">
+            <a:schemeClr val="accent1"/>
+          </a:effectRef>
+          <a:fontRef idx="minor">
+            <a:schemeClr val="tx1"/>
+          </a:fontRef>
+        </p:style>
+      </p:cxnSp>
     </p:spTree>
   </p:cSld>
   <p:clrMapOvr>
@@ -21857,12 +22265,23 @@
           <a:p>
             <a:pPr algn="ctr"/>
             <a:r>
-              <a:rPr sz="2000" b="1" i="0">
+              <a:rPr sz="1200" b="1" i="0">
                 <a:solidFill>
                   <a:srgbClr val="FFFFFF"/>
                 </a:solidFill>
               </a:rPr>
-              <a:t>DEFECTIVE CONTENT</a:t>
+              <a:t>INCOMPATIBLE</a:t>
+            </a:r>
+          </a:p>
+          <a:p>
+            <a:pPr algn="ctr"/>
+            <a:r>
+              <a:rPr sz="1000" b="1" i="0">
+                <a:solidFill>
+                  <a:srgbClr val="FFFFFF"/>
+                </a:solidFill>
+              </a:rPr>
+              <a:t>CONTENT + INTERPRETER</a:t>
             </a:r>
           </a:p>
         </p:txBody>
@@ -21952,7 +22371,7 @@
                   <a:srgbClr val="5C4826"/>
                 </a:solidFill>
               </a:rPr>
-              <a:t>unsafe processing</a:t>
+              <a:t>unsafe access</a:t>
             </a:r>
           </a:p>
         </p:txBody>
@@ -22076,7 +22495,7 @@
                   <a:srgbClr val="5C4826"/>
                 </a:solidFill>
               </a:rPr>
-              <a:t>Model: a component behaved outside its contract.   Intervention: repair the component.</a:t>
+              <a:t>Model: a chain of events traced to a defect.   Intervention: repair the incompatibility.</a:t>
             </a:r>
           </a:p>
         </p:txBody>
@@ -22152,66 +22571,14 @@
       </p:sp>
       <p:sp>
         <p:nvSpPr>
-          <p:cNvPr id="901" name="Block"/>
-          <p:cNvSpPr/>
-          <p:nvPr/>
-        </p:nvSpPr>
-        <p:spPr>
-          <a:xfrm>
-            <a:off x="640080" y="2743200"/>
-            <a:ext cx="2377440" cy="822960"/>
-          </a:xfrm>
-          <a:prstGeom prst="rect">
-            <a:avLst/>
-          </a:prstGeom>
-          <a:solidFill>
-            <a:srgbClr val="9A3F12"/>
-          </a:solidFill>
-          <a:ln>
-            <a:noFill/>
-          </a:ln>
-          <a:effectLst/>
-        </p:spPr>
-        <p:style>
-          <a:lnRef idx="1">
-            <a:schemeClr val="accent1"/>
-          </a:lnRef>
-          <a:fillRef idx="3">
-            <a:schemeClr val="accent1"/>
-          </a:fillRef>
-          <a:effectRef idx="2">
-            <a:schemeClr val="accent1"/>
-          </a:effectRef>
-          <a:fontRef idx="minor">
-            <a:schemeClr val="lt1"/>
-          </a:fontRef>
-        </p:style>
-        <p:txBody>
-          <a:bodyPr wrap="square" lIns="27432" tIns="22860" rIns="27432" bIns="22860" rtlCol="0" anchor="ctr"/>
-          <a:lstStyle/>
-          <a:p>
-            <a:pPr algn="ctr"/>
-            <a:r>
-              <a:rPr sz="2200" b="1" i="0">
-                <a:solidFill>
-                  <a:srgbClr val="FFFFFF"/>
-                </a:solidFill>
-              </a:rPr>
-              <a:t>WHAT WOULD YOU CHANGE?</a:t>
-            </a:r>
-          </a:p>
-        </p:txBody>
-      </p:sp>
-      <p:sp>
-        <p:nvSpPr>
           <p:cNvPr id="902" name="Card"/>
           <p:cNvSpPr/>
           <p:nvPr/>
         </p:nvSpPr>
         <p:spPr>
           <a:xfrm>
-            <a:off x="4876800" y="960120"/>
-            <a:ext cx="3764280" cy="914400"/>
+            <a:off x="1371600" y="1188720"/>
+            <a:ext cx="6400800" cy="1051560"/>
           </a:xfrm>
           <a:prstGeom prst="rect">
             <a:avLst/>
@@ -22280,8 +22647,8 @@
         </p:nvSpPr>
         <p:spPr>
           <a:xfrm>
-            <a:off x="4876800" y="2078037"/>
-            <a:ext cx="3764280" cy="914400"/>
+            <a:off x="1371600" y="2606040"/>
+            <a:ext cx="6400800" cy="1051560"/>
           </a:xfrm>
           <a:prstGeom prst="rect">
             <a:avLst/>
@@ -22350,8 +22717,8 @@
         </p:nvSpPr>
         <p:spPr>
           <a:xfrm>
-            <a:off x="4876800" y="3201670"/>
-            <a:ext cx="3764280" cy="914400"/>
+            <a:off x="1371600" y="4023360"/>
+            <a:ext cx="6400800" cy="1051560"/>
           </a:xfrm>
           <a:prstGeom prst="rect">
             <a:avLst/>
@@ -22407,123 +22774,6 @@
           </a:p>
         </p:txBody>
       </p:sp>
-      <p:cxnSp>
-        <p:nvCxnSpPr>
-          <p:cNvPr id="930" name="Connector 930"/>
-          <p:cNvCxnSpPr>
-            <a:cxnSpLocks/>
-            <a:endCxn id="902" idx="1"/>
-          </p:cNvCxnSpPr>
-          <p:nvPr/>
-        </p:nvCxnSpPr>
-        <p:spPr>
-          <a:xfrm flipV="1">
-            <a:off x="3017520" y="1417320"/>
-            <a:ext cx="1859280" cy="1737360"/>
-          </a:xfrm>
-          <a:prstGeom prst="line">
-            <a:avLst/>
-          </a:prstGeom>
-          <a:ln w="19050">
-            <a:solidFill>
-              <a:srgbClr val="8E6F3E"/>
-            </a:solidFill>
-            <a:tailEnd type="triangle"/>
-          </a:ln>
-        </p:spPr>
-        <p:style>
-          <a:lnRef idx="2">
-            <a:schemeClr val="accent1"/>
-          </a:lnRef>
-          <a:fillRef idx="0">
-            <a:schemeClr val="accent1"/>
-          </a:fillRef>
-          <a:effectRef idx="1">
-            <a:schemeClr val="accent1"/>
-          </a:effectRef>
-          <a:fontRef idx="minor">
-            <a:schemeClr val="tx1"/>
-          </a:fontRef>
-        </p:style>
-      </p:cxnSp>
-      <p:cxnSp>
-        <p:nvCxnSpPr>
-          <p:cNvPr id="931" name="Connector 931"/>
-          <p:cNvCxnSpPr>
-            <a:cxnSpLocks/>
-            <a:endCxn id="904" idx="1"/>
-          </p:cNvCxnSpPr>
-          <p:nvPr/>
-        </p:nvCxnSpPr>
-        <p:spPr>
-          <a:xfrm flipV="1">
-            <a:off x="3017520" y="2535237"/>
-            <a:ext cx="1859280" cy="619443"/>
-          </a:xfrm>
-          <a:prstGeom prst="line">
-            <a:avLst/>
-          </a:prstGeom>
-          <a:ln w="19050">
-            <a:solidFill>
-              <a:srgbClr val="8E6F3E"/>
-            </a:solidFill>
-            <a:tailEnd type="triangle"/>
-          </a:ln>
-        </p:spPr>
-        <p:style>
-          <a:lnRef idx="2">
-            <a:schemeClr val="accent1"/>
-          </a:lnRef>
-          <a:fillRef idx="0">
-            <a:schemeClr val="accent1"/>
-          </a:fillRef>
-          <a:effectRef idx="1">
-            <a:schemeClr val="accent1"/>
-          </a:effectRef>
-          <a:fontRef idx="minor">
-            <a:schemeClr val="tx1"/>
-          </a:fontRef>
-        </p:style>
-      </p:cxnSp>
-      <p:cxnSp>
-        <p:nvCxnSpPr>
-          <p:cNvPr id="932" name="Connector 932"/>
-          <p:cNvCxnSpPr>
-            <a:cxnSpLocks/>
-            <a:endCxn id="906" idx="1"/>
-          </p:cNvCxnSpPr>
-          <p:nvPr/>
-        </p:nvCxnSpPr>
-        <p:spPr>
-          <a:xfrm>
-            <a:off x="3017520" y="3154680"/>
-            <a:ext cx="1859280" cy="504190"/>
-          </a:xfrm>
-          <a:prstGeom prst="line">
-            <a:avLst/>
-          </a:prstGeom>
-          <a:ln w="19050">
-            <a:solidFill>
-              <a:srgbClr val="8E6F3E"/>
-            </a:solidFill>
-            <a:tailEnd type="triangle"/>
-          </a:ln>
-        </p:spPr>
-        <p:style>
-          <a:lnRef idx="2">
-            <a:schemeClr val="accent1"/>
-          </a:lnRef>
-          <a:fillRef idx="0">
-            <a:schemeClr val="accent1"/>
-          </a:fillRef>
-          <a:effectRef idx="1">
-            <a:schemeClr val="accent1"/>
-          </a:effectRef>
-          <a:fontRef idx="minor">
-            <a:schemeClr val="tx1"/>
-          </a:fontRef>
-        </p:style>
-      </p:cxnSp>
       <p:sp>
         <p:nvSpPr>
           <p:cNvPr id="2" name="FooterBand"/>
@@ -23080,8 +23330,8 @@
         </p:nvSpPr>
         <p:spPr>
           <a:xfrm>
-            <a:off x="3840480" y="1188720"/>
-            <a:ext cx="4754880" cy="566928"/>
+            <a:off x="4343400" y="1188720"/>
+            <a:ext cx="4526280" cy="566928"/>
           </a:xfrm>
           <a:prstGeom prst="rect">
             <a:avLst/>
@@ -23130,8 +23380,8 @@
         </p:nvSpPr>
         <p:spPr>
           <a:xfrm>
-            <a:off x="3840480" y="2029968"/>
-            <a:ext cx="4754880" cy="566928"/>
+            <a:off x="4343400" y="2029968"/>
+            <a:ext cx="4526280" cy="566928"/>
           </a:xfrm>
           <a:prstGeom prst="rect">
             <a:avLst/>
@@ -23180,8 +23430,8 @@
         </p:nvSpPr>
         <p:spPr>
           <a:xfrm>
-            <a:off x="3840480" y="2871216"/>
-            <a:ext cx="4754880" cy="566928"/>
+            <a:off x="4343400" y="2871216"/>
+            <a:ext cx="4526280" cy="566928"/>
           </a:xfrm>
           <a:prstGeom prst="rect">
             <a:avLst/>
@@ -23230,8 +23480,8 @@
         </p:nvSpPr>
         <p:spPr>
           <a:xfrm>
-            <a:off x="3840480" y="4169664"/>
-            <a:ext cx="4754880" cy="566928"/>
+            <a:off x="4343400" y="4169664"/>
+            <a:ext cx="4526280" cy="566928"/>
           </a:xfrm>
           <a:prstGeom prst="rect">
             <a:avLst/>
@@ -23280,8 +23530,8 @@
         </p:nvSpPr>
         <p:spPr>
           <a:xfrm>
-            <a:off x="3840480" y="5010912"/>
-            <a:ext cx="4754880" cy="566928"/>
+            <a:off x="4343400" y="5010912"/>
+            <a:ext cx="4526280" cy="566928"/>
           </a:xfrm>
           <a:prstGeom prst="rect">
             <a:avLst/>
@@ -23494,6 +23744,186 @@
           </a:p>
         </p:txBody>
       </p:sp>
+      <p:cxnSp>
+        <p:nvCxnSpPr>
+          <p:cNvPr id="911" name="Connector 911"/>
+          <p:cNvCxnSpPr/>
+          <p:nvPr/>
+        </p:nvCxnSpPr>
+        <p:spPr>
+          <a:xfrm>
+            <a:off x="3657600" y="1472184"/>
+            <a:ext cx="685800" cy="0"/>
+          </a:xfrm>
+          <a:prstGeom prst="line">
+            <a:avLst/>
+          </a:prstGeom>
+          <a:ln w="28575">
+            <a:solidFill>
+              <a:srgbClr val="8E6F3E"/>
+            </a:solidFill>
+            <a:tailEnd type="triangle"/>
+          </a:ln>
+        </p:spPr>
+        <p:style>
+          <a:lnRef idx="2">
+            <a:schemeClr val="accent1"/>
+          </a:lnRef>
+          <a:fillRef idx="0">
+            <a:schemeClr val="accent1"/>
+          </a:fillRef>
+          <a:effectRef idx="1">
+            <a:schemeClr val="accent1"/>
+          </a:effectRef>
+          <a:fontRef idx="minor">
+            <a:schemeClr val="tx1"/>
+          </a:fontRef>
+        </p:style>
+      </p:cxnSp>
+      <p:cxnSp>
+        <p:nvCxnSpPr>
+          <p:cNvPr id="911" name="Connector 911"/>
+          <p:cNvCxnSpPr/>
+          <p:nvPr/>
+        </p:nvCxnSpPr>
+        <p:spPr>
+          <a:xfrm>
+            <a:off x="3657600" y="2313432"/>
+            <a:ext cx="685800" cy="0"/>
+          </a:xfrm>
+          <a:prstGeom prst="line">
+            <a:avLst/>
+          </a:prstGeom>
+          <a:ln w="28575">
+            <a:solidFill>
+              <a:srgbClr val="8E6F3E"/>
+            </a:solidFill>
+            <a:tailEnd type="triangle"/>
+          </a:ln>
+        </p:spPr>
+        <p:style>
+          <a:lnRef idx="2">
+            <a:schemeClr val="accent1"/>
+          </a:lnRef>
+          <a:fillRef idx="0">
+            <a:schemeClr val="accent1"/>
+          </a:fillRef>
+          <a:effectRef idx="1">
+            <a:schemeClr val="accent1"/>
+          </a:effectRef>
+          <a:fontRef idx="minor">
+            <a:schemeClr val="tx1"/>
+          </a:fontRef>
+        </p:style>
+      </p:cxnSp>
+      <p:cxnSp>
+        <p:nvCxnSpPr>
+          <p:cNvPr id="911" name="Connector 911"/>
+          <p:cNvCxnSpPr/>
+          <p:nvPr/>
+        </p:nvCxnSpPr>
+        <p:spPr>
+          <a:xfrm>
+            <a:off x="3657600" y="3154680"/>
+            <a:ext cx="685800" cy="0"/>
+          </a:xfrm>
+          <a:prstGeom prst="line">
+            <a:avLst/>
+          </a:prstGeom>
+          <a:ln w="28575">
+            <a:solidFill>
+              <a:srgbClr val="8E6F3E"/>
+            </a:solidFill>
+            <a:tailEnd type="triangle"/>
+          </a:ln>
+        </p:spPr>
+        <p:style>
+          <a:lnRef idx="2">
+            <a:schemeClr val="accent1"/>
+          </a:lnRef>
+          <a:fillRef idx="0">
+            <a:schemeClr val="accent1"/>
+          </a:fillRef>
+          <a:effectRef idx="1">
+            <a:schemeClr val="accent1"/>
+          </a:effectRef>
+          <a:fontRef idx="minor">
+            <a:schemeClr val="tx1"/>
+          </a:fontRef>
+        </p:style>
+      </p:cxnSp>
+      <p:cxnSp>
+        <p:nvCxnSpPr>
+          <p:cNvPr id="911" name="Connector 911"/>
+          <p:cNvCxnSpPr/>
+          <p:nvPr/>
+        </p:nvCxnSpPr>
+        <p:spPr>
+          <a:xfrm>
+            <a:off x="3657600" y="4453127"/>
+            <a:ext cx="685800" cy="0"/>
+          </a:xfrm>
+          <a:prstGeom prst="line">
+            <a:avLst/>
+          </a:prstGeom>
+          <a:ln w="28575">
+            <a:solidFill>
+              <a:srgbClr val="8E6F3E"/>
+            </a:solidFill>
+            <a:tailEnd type="triangle"/>
+          </a:ln>
+        </p:spPr>
+        <p:style>
+          <a:lnRef idx="2">
+            <a:schemeClr val="accent1"/>
+          </a:lnRef>
+          <a:fillRef idx="0">
+            <a:schemeClr val="accent1"/>
+          </a:fillRef>
+          <a:effectRef idx="1">
+            <a:schemeClr val="accent1"/>
+          </a:effectRef>
+          <a:fontRef idx="minor">
+            <a:schemeClr val="tx1"/>
+          </a:fontRef>
+        </p:style>
+      </p:cxnSp>
+      <p:cxnSp>
+        <p:nvCxnSpPr>
+          <p:cNvPr id="911" name="Connector 911"/>
+          <p:cNvCxnSpPr/>
+          <p:nvPr/>
+        </p:nvCxnSpPr>
+        <p:spPr>
+          <a:xfrm>
+            <a:off x="3657600" y="5294376"/>
+            <a:ext cx="685800" cy="0"/>
+          </a:xfrm>
+          <a:prstGeom prst="line">
+            <a:avLst/>
+          </a:prstGeom>
+          <a:ln w="28575">
+            <a:solidFill>
+              <a:srgbClr val="8E6F3E"/>
+            </a:solidFill>
+            <a:tailEnd type="triangle"/>
+          </a:ln>
+        </p:spPr>
+        <p:style>
+          <a:lnRef idx="2">
+            <a:schemeClr val="accent1"/>
+          </a:lnRef>
+          <a:fillRef idx="0">
+            <a:schemeClr val="accent1"/>
+          </a:fillRef>
+          <a:effectRef idx="1">
+            <a:schemeClr val="accent1"/>
+          </a:effectRef>
+          <a:fontRef idx="minor">
+            <a:schemeClr val="tx1"/>
+          </a:fontRef>
+        </p:style>
+      </p:cxnSp>
     </p:spTree>
   </p:cSld>
   <p:clrMapOvr>
@@ -24689,7 +25119,7 @@
                   <a:srgbClr val="FFFFFF"/>
                 </a:solidFill>
               </a:rPr>
-              <a:t>Two defenses were missing. One ran — and checked the wrong property.</a:t>
+              <a:t>Two defenses missing · one coverage gap · one ran against the wrong contract</a:t>
             </a:r>
           </a:p>
           <a:p>

</xml_diff>

<commit_message>
deck 2-4: FMEA pass — end by predicting, then grading the prediction (28 -> 30 slides)
New slide 26 works FMEA on the known CrowdStrike case; new slide 27 gives
Cloudflare's architecture only plus a blank worksheet; the existing incident
slide moves 26 -> 28 as the reveal (sldIdLst reorder, relationship intact);
the diagnosis exercise gains the closing FMEA question; the closer is
unchanged. Slides 21-25 compress 11 -> 5 minutes to fund the 6 FMEA minutes;
TIMING sum stays 75. FMEA framed as a prospective search method, not a fourth
causal model; occurrence left '?'; RPN limitation + AIAG/VDA Action Priority
in speaker notes only; no student reading added. Facts: no new incident
claims; method references recorded in VERIFIED-FACTS.
</commit_message>
<xml_diff>
--- a/book/_design/2-4-redux-build/2-4-redux-WIP.pptx
+++ b/book/_design/2-4-redux-build/2-4-redux-WIP.pptx
@@ -33,6 +33,8 @@
     <p:sldId id="325" r:id="rId63"/>
     <p:sldId id="326" r:id="rId64"/>
     <p:sldId id="327" r:id="rId65"/>
+    <p:sldId id="331" r:id="rId35"/>
+    <p:sldId id="332" r:id="rId34"/>
     <p:sldId id="328" r:id="rId66"/>
     <p:sldId id="329" r:id="rId67"/>
     <p:sldId id="330" r:id="rId68"/>
@@ -1124,7 +1126,7 @@
           </a:p>
           <a:p>
             <a:r>
-              <a:t>BUDGET: the TIMING lines across the deck now sum to 75 minutes, with the slide-6 commitment discussion and the slide-27 transfer exercise protected.</a:t>
+              <a:t>BUDGET: the TIMING lines across the deck now sum to 75 minutes, with the slide-6 commitment discussion, the slide-27 FMEA transfer exercise, and the slide-29 diagnosis exercise protected.</a:t>
             </a:r>
           </a:p>
         </p:txBody>
@@ -1137,6 +1139,211 @@
           </p:cNvSpPr>
           <p:nvPr>
             <p:ph type="sldNum" sz="quarter" idx="5"/>
+          </p:nvPr>
+        </p:nvSpPr>
+        <p:spPr/>
+      </p:sp>
+    </p:spTree>
+  </p:cSld>
+  <p:clrMapOvr>
+    <a:masterClrMapping/>
+  </p:clrMapOvr>
+</p:notes>
+</file>
+
+<file path=ppt/notesSlides/notesSlide29.xml><?xml version="1.0" encoding="utf-8"?>
+<p:notes xmlns:a="http://schemas.openxmlformats.org/drawingml/2006/main" xmlns:p="http://schemas.openxmlformats.org/presentationml/2006/main" xmlns:r="http://schemas.openxmlformats.org/officeDocument/2006/relationships">
+  <p:cSld>
+    <p:spTree>
+      <p:nvGrpSpPr>
+        <p:cNvPr id="1" name=""/>
+        <p:cNvGrpSpPr/>
+        <p:nvPr/>
+      </p:nvGrpSpPr>
+      <p:grpSpPr>
+        <a:xfrm>
+          <a:off x="0" y="0"/>
+          <a:ext cx="0" cy="0"/>
+          <a:chOff x="0" y="0"/>
+          <a:chExt cx="0" cy="0"/>
+        </a:xfrm>
+      </p:grpSpPr>
+      <p:sp>
+        <p:nvSpPr>
+          <p:cNvPr id="2" name="Slide Image Placeholder 1"/>
+          <p:cNvSpPr>
+            <a:spLocks noGrp="1"/>
+          </p:cNvSpPr>
+          <p:nvPr>
+            <p:ph type="sldImg" idx="2"/>
+          </p:nvPr>
+        </p:nvSpPr>
+        <p:spPr/>
+      </p:sp>
+      <p:sp>
+        <p:nvSpPr>
+          <p:cNvPr id="3" name="Notes Placeholder 2"/>
+          <p:cNvSpPr>
+            <a:spLocks noGrp="1"/>
+          </p:cNvSpPr>
+          <p:nvPr>
+            <p:ph type="body" idx="3" sz="quarter"/>
+          </p:nvPr>
+        </p:nvSpPr>
+        <p:spPr/>
+        <p:txBody>
+          <a:bodyPr/>
+          <a:lstStyle/>
+          <a:p>
+            <a:r>
+              <a:t>TIMING: 3 minutes. NEW METHOD — prospective, not explanatory.</a:t>
+            </a:r>
+          </a:p>
+          <a:p>
+            <a:r>
+              <a:t>ENGINEERING POINT: the three models EXPLAIN a failure that has happened. FMEA — Failure Mode and Effects Analysis (IEC 60812:2018) — is not a fourth explanation: it is a structured method for SEARCHING for potential failures and deciding what deserves attention, before anything fails. Nor is it component-only — by scope it can examine functions, interfaces, operational processes, or organizational activities. Do not teach 'FMEA = components, STAMP = systems.'</a:t>
+            </a:r>
+          </a:p>
+          <a:p>
+            <a:r>
+              <a:t>THE WORKED TABLE: each row: a FUNCTION of the system we know thoroughly, a failure mode, its effect, a candidate control — all met on slides 21–25.</a:t>
+            </a:r>
+          </a:p>
+          <a:p>
+            <a:r>
+              <a:t>CARE — the staged-rollout row (cross-reference slide 25): HAVING a staged-rollout mechanism is not the same as having one that reliably detects and contains the failure mode; a rollout that advances without meaningful health checks offers little protection.</a:t>
+            </a:r>
+          </a:p>
+          <a:p>
+            <a:r>
+              <a:t>RATINGS (notes only): classical FMEA multiplies severity, occurrence, and detection into a Risk Priority Number — but multiplying ordinal ratings does not make an RPN of 120 twice the risk of 60; the AIAG &amp; VDA FMEA Handbook (1st ed., 2019) replaces RPN with Action Priority. Occurrence stays '?' deliberately: the method's value is exposing uncertainty, not manufacturing numerical certainty.</a:t>
+            </a:r>
+          </a:p>
+          <a:p>
+            <a:r>
+              <a:t>ASK (the footer): which of these failure modes could occur in another security product? Expected: the validate / distribute / maintain rows do not depend on the content-interpreter defect at all.</a:t>
+            </a:r>
+          </a:p>
+          <a:p>
+            <a:r>
+              <a:t>INSTRUCTOR REFERENCES (no student reading assigned): IEC 60812:2018; AIAG &amp; VDA FMEA Handbook, 1st ed., 2019.</a:t>
+            </a:r>
+          </a:p>
+          <a:p>
+            <a:r>
+              <a:t>TRANSITION: if those rows transfer, the method should work on a system we know nothing about. Next: exactly that.</a:t>
+            </a:r>
+          </a:p>
+        </p:txBody>
+      </p:sp>
+      <p:sp>
+        <p:nvSpPr>
+          <p:cNvPr id="4" name="Slide Number Placeholder 3"/>
+          <p:cNvSpPr>
+            <a:spLocks noGrp="1"/>
+          </p:cNvSpPr>
+          <p:nvPr>
+            <p:ph type="sldNum" idx="5" sz="quarter"/>
+          </p:nvPr>
+        </p:nvSpPr>
+        <p:spPr/>
+      </p:sp>
+    </p:spTree>
+  </p:cSld>
+  <p:clrMapOvr>
+    <a:masterClrMapping/>
+  </p:clrMapOvr>
+</p:notes>
+</file>
+
+<file path=ppt/notesSlides/notesSlide30.xml><?xml version="1.0" encoding="utf-8"?>
+<p:notes xmlns:a="http://schemas.openxmlformats.org/drawingml/2006/main" xmlns:p="http://schemas.openxmlformats.org/presentationml/2006/main" xmlns:r="http://schemas.openxmlformats.org/officeDocument/2006/relationships">
+  <p:cSld>
+    <p:spTree>
+      <p:nvGrpSpPr>
+        <p:cNvPr id="1" name=""/>
+        <p:cNvGrpSpPr/>
+        <p:nvPr/>
+      </p:nvGrpSpPr>
+      <p:grpSpPr>
+        <a:xfrm>
+          <a:off x="0" y="0"/>
+          <a:ext cx="0" cy="0"/>
+          <a:chOff x="0" y="0"/>
+          <a:chExt cx="0" cy="0"/>
+        </a:xfrm>
+      </p:grpSpPr>
+      <p:sp>
+        <p:nvSpPr>
+          <p:cNvPr id="2" name="Slide Image Placeholder 1"/>
+          <p:cNvSpPr>
+            <a:spLocks noGrp="1"/>
+          </p:cNvSpPr>
+          <p:nvPr>
+            <p:ph type="sldImg" idx="2"/>
+          </p:nvPr>
+        </p:nvSpPr>
+        <p:spPr/>
+      </p:sp>
+      <p:sp>
+        <p:nvSpPr>
+          <p:cNvPr id="3" name="Notes Placeholder 2"/>
+          <p:cNvSpPr>
+            <a:spLocks noGrp="1"/>
+          </p:cNvSpPr>
+          <p:nvPr>
+            <p:ph type="body" idx="3" sz="quarter"/>
+          </p:nvPr>
+        </p:nvSpPr>
+        <p:spPr/>
+        <p:txBody>
+          <a:bodyPr/>
+          <a:lstStyle/>
+          <a:p>
+            <a:r>
+              <a:t>TIMING: 3 minutes — present the architecture in under one minute; PROTECT 2–3 minutes for the worksheet discussion (author pacing note).</a:t>
+            </a:r>
+          </a:p>
+          <a:p>
+            <a:r>
+              <a:t>ENGINEERING POINT: transfer of the METHOD, not recall of an incident. Students get only the architecture — four facts — and must search it for failure modes under genuinely incomplete information, the condition engineers actually work in. DO NOT reveal what happened in 2019; if a student already knows the incident, ask them to hold it.</a:t>
+            </a:r>
+          </a:p>
+          <a:p>
+            <a:r>
+              <a:t>FACTUAL BACKGROUND (architecture only; source: Cloudflare post-mortem, 'Details of the Cloudflare outage on July 2, 2019'): Cloudflare operates a Web Application Firewall that inspects incoming web requests; engineers can deploy new detection rules without releasing new software; some rules use regular expressions; rule changes can propagate globally within seconds.</a:t>
+            </a:r>
+          </a:p>
+          <a:p>
+            <a:r>
+              <a:t>RUN IT: pairs, at least one failure mode per function row; leave occurrence '?' and ask which modes warrant a control anyway.</a:t>
+            </a:r>
+          </a:p>
+          <a:p>
+            <a:r>
+              <a:t>EXPECTED ANSWERS — all legitimate WITHOUT knowing the incident: a rule that consumes excessive CPU or memory; a rule that false-positives and blocks legitimate traffic; a malformed rule that breaks evaluation; a defective rule reaching every server before anyone can detect or halt it. Students do NOT need to anticipate catastrophic regex backtracking: the general failure mode is the method's product; the precise defect is hindsight's.</a:t>
+            </a:r>
+          </a:p>
+          <a:p>
+            <a:r>
+              <a:t>MISCONCEPTION: a guessing game about 'the real outage.' Grade on search discipline, not prophecy.</a:t>
+            </a:r>
+          </a:p>
+          <a:p>
+            <a:r>
+              <a:t>TRANSITION: let's see what actually happened — and compare it against your table.</a:t>
+            </a:r>
+          </a:p>
+        </p:txBody>
+      </p:sp>
+      <p:sp>
+        <p:nvSpPr>
+          <p:cNvPr id="4" name="Slide Number Placeholder 3"/>
+          <p:cNvSpPr>
+            <a:spLocks noGrp="1"/>
+          </p:cNvSpPr>
+          <p:nvPr>
+            <p:ph type="sldNum" idx="5" sz="quarter"/>
           </p:nvPr>
         </p:nvSpPr>
         <p:spPr/>
@@ -3169,7 +3376,7 @@
           <a:lstStyle/>
           <a:p>
             <a:r>
-              <a:t>TIMING: 2 minutes. OPENS MOVEMENT 4 — what should change?</a:t>
+              <a:t>TIMING: 1 minutes. OPENS MOVEMENT 4 — what should change? DELIVER EFFICIENTLY (author pacing note): present the ladder and pose the footer question rhetorically — this movement's active-learning weight now lives in the FMEA exercise (slide 27) and the diagnosis exercise (slide 29).</a:t>
             </a:r>
           </a:p>
           <a:p>
@@ -3269,7 +3476,7 @@
           <a:lstStyle/>
           <a:p>
             <a:r>
-              <a:t>TIMING: 2 minutes. PRESERVED FROM THE ORIGINAL LECTURE — Schön's contribution.</a:t>
+              <a:t>TIMING: 1 minutes. PRESERVED FROM THE ORIGINAL LECTURE — Schön's contribution. Deliver as exposition; fold the footer question into the transition rather than opening a discussion.</a:t>
             </a:r>
           </a:p>
           <a:p>
@@ -3379,7 +3586,7 @@
           <a:lstStyle/>
           <a:p>
             <a:r>
-              <a:t>TIMING: 3 minutes. GOVERNANCE CONVERSION — the lesson changes the ENVIRONMENT.</a:t>
+              <a:t>TIMING: 1 minutes. GOVERNANCE CONVERSION — the lesson changes the ENVIRONMENT.</a:t>
             </a:r>
           </a:p>
           <a:p>
@@ -3394,7 +3601,7 @@
           </a:p>
           <a:p>
             <a:r>
-              <a:t>ANIMATION-IN-SPEECH: cover the right column; ask students to propose the artifact for each left-hand diagnosis before revealing.</a:t>
+              <a:t>PACING (author): the cover-the-right-column reveal is CUT for time — walk the rows directly and state the slide-9 contrast yourself; the FMEA exercise two slides ahead carries this movement's active learning.</a:t>
             </a:r>
           </a:p>
           <a:p>
@@ -3484,7 +3691,7 @@
           <a:lstStyle/>
           <a:p>
             <a:r>
-              <a:t>TIMING: 2 minutes. THE LOCAL AND SYSTEMIC ANALYSES MEET.</a:t>
+              <a:t>TIMING: 1 minutes. THE LOCAL AND SYSTEMIC ANALYSES MEET. Pose the footer question, take ONE answer, state the recognition yourself.</a:t>
             </a:r>
           </a:p>
           <a:p>
@@ -3579,7 +3786,7 @@
           <a:lstStyle/>
           <a:p>
             <a:r>
-              <a:t>TIMING: 2 minutes. CLOSES THE CROWDSTRIKE INVESTIGATION.</a:t>
+              <a:t>TIMING: 1 minutes. CLOSES THE CROWDSTRIKE INVESTIGATION. Walk the rows briskly — the next slide re-invokes this slide's lesson (a control's existence is not evidence of its effectiveness) inside the FMEA's staged-rollout row.</a:t>
             </a:r>
           </a:p>
           <a:p>
@@ -3604,7 +3811,7 @@
           </a:p>
           <a:p>
             <a:r>
-              <a:t>TRANSITION: we built a method on one incident. If the method is real, it should transfer. New incident, five years earlier, different company.</a:t>
+              <a:t>TRANSITION: everything so far reasons BACKWARD from a failure that already happened. Can the discipline run FORWARD — before any failure occurs? Next: a structured method for searching for failures in advance, tried first on the incident we now know thoroughly.</a:t>
             </a:r>
           </a:p>
         </p:txBody>
@@ -3674,32 +3881,37 @@
           <a:lstStyle/>
           <a:p>
             <a:r>
-              <a:t>TIMING: 3 minutes — a transfer exercise, not a second full case study.</a:t>
-            </a:r>
-          </a:p>
-          <a:p>
-            <a:r>
-              <a:t>EXPOSITION ORDER (author): establish the system first. Cloudflare operates an edge network a large share of web traffic passes through; a Web Application Firewall (WAF) inspects that traffic for attacks; WAF rules describe attack patterns, often as regular expressions. THEN the failure — and explain the MECHANISM before the measurements: some regular expressions require disproportionately more matching work as the input grows, because a backtracking engine re-tries overlapping ways to match. The 23-vs-555 bars at the bottom ILLUSTRATE that mechanism; they do not replace the explanation.</a:t>
-            </a:r>
-          </a:p>
-          <a:p>
-            <a:r>
-              <a:t>FACTS (Cloudflare post-mortem, 'Details of the Cloudflare outage on July 2, 2019'): a WAF Managed Rule targeting XSS deployed globally at 13:42 UTC — in seconds, with no staged rollout, while software releases went DOG → PIG → Canary; the sub-pattern .*(?:.*=.*) caused catastrophic backtracking (their worked numbers: 'x=x' took 23 steps; 'x=' plus twenty 'x's took 555); PCRE 'has no mechanism to protect against a runaway expression'; WAF identified 14:00, killed globally 14:07, traffic normal 14:09, re-enabled 14:52 — 27 minutes of impact. A CPU protection had been accidentally removed weeks earlier.</a:t>
-            </a:r>
-          </a:p>
-          <a:p>
-            <a:r>
-              <a:t>DEEP STRUCTURE (lead with it at the footer): in both incidents, content or configuration shipped through a faster, less-gated path than code; and in both, a validator ran and passed while checking the wrong property — arity against the wrong contract at CrowdStrike, runtime instead of CPU at Cloudflare.</a:t>
+              <a:t>TIMING: 3 minutes — the reveal. Grade the class's FMEA predictions against the incident.</a:t>
+            </a:r>
+          </a:p>
+          <a:p>
+            <a:r>
+              <a:t>ENGINEERING POINT: compare prediction with reality, and name the gap honestly. Most groups will have proposed a resource-exhaustion or bad-rule failure mode, a service-disruption effect, and controls such as pre-deployment resource limits or a staged rollout — without knowing anything about 2019. Nobody should be expected to have named catastrophic regex backtracking: FMEA surfaces the GENERAL failure mode; it does not predict the specific defect. In hindsight every failure looks foreseeable; in practice engineers work under incomplete information.</a:t>
+            </a:r>
+          </a:p>
+          <a:p>
+            <a:r>
+              <a:t>EXPOSITION ORDER (author): the class met only the architecture on the previous slide, so establish the rest of the system briefly, then the failure — MECHANISM before measurements: some regular expressions require disproportionately more matching work as the input grows, because a backtracking engine re-tries overlapping ways to match. The 23-vs-555 bars at the bottom ILLUSTRATE that mechanism; they do not replace the explanation.</a:t>
+            </a:r>
+          </a:p>
+          <a:p>
+            <a:r>
+              <a:t>FACTS (Cloudflare post-mortem, 'Details of the Cloudflare outage on July 2, 2019'): a WAF Managed Rule targeting XSS deployed globally at 13:42 UTC — in seconds, with no staged rollout, while software releases went DOG → PIG → Canary; the sub-pattern .*(?:.*=.*) caused catastrophic backtracking (their worked numbers: 'x=x' took 23 steps; 'x=' plus twenty 'x's took 555); PCRE 'has no mechanism to protect against a runaway expression'; WAF identified 14:00, killed globally 14:07, traffic normal 14:09, re-enabled 14:52 — 27 minutes of impact. A CPU-usage protection had been accidentally removed weeks earlier.</a:t>
+            </a:r>
+          </a:p>
+          <a:p>
+            <a:r>
+              <a:t>ASK (the footer's first line): which failure modes did we anticipate — and which did we miss? Typically anticipated: a defective rule, global distribution, nothing to halt it. Typically missed: the removed CPU protection, and a test suite that measured runtime rather than CPU — defenses that existed and failed, which the diagnosis exercise next can surface.</a:t>
+            </a:r>
+          </a:p>
+          <a:p>
+            <a:r>
+              <a:t>DEEP STRUCTURE (the footer's second line — let students state it before you do): in both incidents, a security configuration update is distributed globally without adequate opportunities to detect and contain defective updates; and in both, a validator ran and passed while checking the wrong property — arity against the wrong contract at CrowdStrike, runtime instead of CPU at Cloudflare. An engineer could identify that characteristic prospectively in either system — which is what the previous two slides had students do.</a:t>
             </a:r>
           </a:p>
           <a:p>
             <a:r>
               <a:t>CARE: regex matching cost depends on expression, engine, AND input — do not imply all engines behave this way (re2 and Rust's engine carry runtime guarantees). Do not conflate with Cloudflare's November 2025 outage — different mechanism.</a:t>
-            </a:r>
-          </a:p>
-          <a:p>
-            <a:r>
-              <a:t>ASK: what in this story have you already seen this lecture?</a:t>
             </a:r>
           </a:p>
           <a:p>
@@ -3790,6 +4002,11 @@
           <a:p>
             <a:r>
               <a:t>GRADING STANCE: do not reward choosing the broadest model. Reward an intervention justified by the model and the evidence, addressing a consequential failure class at acceptable cost.</a:t>
+            </a:r>
+          </a:p>
+          <a:p>
+            <a:r>
+              <a:t>CLOSING QUESTION (the footer's last line): how should this incident change the FMEA for future WAF releases? Expected: new failure-mode rows (a rule whose matching cost explodes on ordinary input); a detection column that measures CPU, not wall-clock runtime; controls promoted from candidate to required — staged rollout for rules, a regex engine with runtime guarantees, a restored and protected CPU limit. The durable point: an FMEA is a living document — each incident updates the search. That is how failure changes FUTURE engineering, which is the closing slide's claim.</a:t>
             </a:r>
           </a:p>
           <a:p>
@@ -19164,7 +19381,7 @@
                   <a:srgbClr val="000000"/>
                 </a:solidFill>
               </a:rPr>
-              <a:t>July 2, 2019: Cloudflare’s WAF outage</a:t>
+              <a:t>What actually happened? July 2, 2019</a:t>
             </a:r>
           </a:p>
         </p:txBody>
@@ -19239,7 +19456,7 @@
                   <a:srgbClr val="FFFFFF"/>
                 </a:solidFill>
               </a:rPr>
-              <a:t>How could one regular expression disrupt a global service?</a:t>
+              <a:t>Which failure modes did we anticipate — and which did we miss?</a:t>
             </a:r>
           </a:p>
           <a:p>
@@ -20395,7 +20612,7 @@
                   <a:schemeClr val="bg1"/>
                 </a:solidFill>
               </a:rPr>
-              <a:t>decide where the lesson should live.</a:t>
+              <a:t>decide where the lesson should live. What evidence would establish that it works?</a:t>
             </a:r>
           </a:p>
           <a:p>
@@ -20406,7 +20623,7 @@
                   <a:schemeClr val="bg1"/>
                 </a:solidFill>
               </a:rPr>
-              <a:t>What evidence would establish that your intervention works?</a:t>
+              <a:t>How should this incident change the FMEA for future WAF releases?</a:t>
             </a:r>
           </a:p>
         </p:txBody>
@@ -21332,6 +21549,1305 @@
 </p:sld>
 </file>
 
+<file path=ppt/slides/slide29.xml><?xml version="1.0" encoding="utf-8"?>
+<p:sld xmlns:a="http://schemas.openxmlformats.org/drawingml/2006/main" xmlns:p="http://schemas.openxmlformats.org/presentationml/2006/main" xmlns:r="http://schemas.openxmlformats.org/officeDocument/2006/relationships">
+  <p:cSld>
+    <p:spTree>
+      <p:nvGrpSpPr>
+        <p:cNvPr id="1" name=""/>
+        <p:cNvGrpSpPr/>
+        <p:nvPr/>
+      </p:nvGrpSpPr>
+      <p:grpSpPr/>
+      <p:sp>
+        <p:nvSpPr>
+          <p:cNvPr id="3" name="Title 2"/>
+          <p:cNvSpPr>
+            <a:spLocks noGrp="1"/>
+          </p:cNvSpPr>
+          <p:nvPr>
+            <p:ph type="title"/>
+          </p:nvPr>
+        </p:nvSpPr>
+        <p:spPr>
+          <a:xfrm>
+            <a:off x="277148" y="118428"/>
+            <a:ext cx="9145148" cy="638175"/>
+          </a:xfrm>
+        </p:spPr>
+        <p:txBody>
+          <a:bodyPr>
+            <a:normAutofit fontScale="90000"/>
+          </a:bodyPr>
+          <a:lstStyle/>
+          <a:p>
+            <a:r>
+              <a:rPr lang="en-US" sz="2400" i="1" dirty="0">
+                <a:solidFill>
+                  <a:srgbClr val="000000"/>
+                </a:solidFill>
+              </a:rPr>
+              <a:t>Could we have anticipated this failure?</a:t>
+            </a:r>
+          </a:p>
+        </p:txBody>
+      </p:sp>
+      <p:sp>
+        <p:nvSpPr>
+          <p:cNvPr id="900" name="Slide Number Placeholder 900"/>
+          <p:cNvSpPr>
+            <a:spLocks noGrp="1"/>
+          </p:cNvSpPr>
+          <p:nvPr>
+            <p:ph type="sldNum" sz="quarter" idx="4"/>
+          </p:nvPr>
+        </p:nvSpPr>
+        <p:spPr/>
+        <p:txBody>
+          <a:bodyPr/>
+          <a:lstStyle/>
+          <a:p>
+            <a:fld id="{54DE72B0-FFEB-4C83-B4BD-F25961BEDFCA}" type="slidenum">
+              <a:rPr lang="en-US" smtClean="0"/>
+              <a:t>29</a:t>
+            </a:fld>
+            <a:endParaRPr lang="en-US"/>
+          </a:p>
+        </p:txBody>
+      </p:sp>
+      <p:sp>
+        <p:nvSpPr>
+          <p:cNvPr id="903" name="Card"/>
+          <p:cNvSpPr/>
+          <p:nvPr/>
+        </p:nvSpPr>
+        <p:spPr>
+          <a:xfrm>
+            <a:off x="2103120" y="1920240"/>
+            <a:ext cx="2194560" cy="713232"/>
+          </a:xfrm>
+          <a:prstGeom prst="rect">
+            <a:avLst/>
+          </a:prstGeom>
+          <a:solidFill>
+            <a:srgbClr val="F5F1E8"/>
+          </a:solidFill>
+          <a:ln w="12700">
+            <a:solidFill>
+              <a:srgbClr val="C9B991"/>
+            </a:solidFill>
+          </a:ln>
+          <a:effectLst/>
+        </p:spPr>
+        <p:style>
+          <a:lnRef idx="1">
+            <a:schemeClr val="accent1"/>
+          </a:lnRef>
+          <a:fillRef idx="3">
+            <a:schemeClr val="accent1"/>
+          </a:fillRef>
+          <a:effectRef idx="2">
+            <a:schemeClr val="accent1"/>
+          </a:effectRef>
+          <a:fontRef idx="minor">
+            <a:schemeClr val="lt1"/>
+          </a:fontRef>
+        </p:style>
+        <p:txBody>
+          <a:bodyPr wrap="square" lIns="27432" tIns="22860" rIns="27432" bIns="22860" rtlCol="0" anchor="ctr"/>
+          <a:lstStyle/>
+          <a:p>
+            <a:pPr algn="ctr"/>
+            <a:r>
+              <a:rPr sz="1100" b="0" i="1" dirty="0">
+                <a:solidFill>
+                  <a:srgbClr val="5C4826"/>
+                </a:solidFill>
+              </a:rPr>
+              <a:t>invalid content causes unsafe execution</a:t>
+            </a:r>
+          </a:p>
+        </p:txBody>
+      </p:sp>
+      <p:sp>
+        <p:nvSpPr>
+          <p:cNvPr id="907" name="Card"/>
+          <p:cNvSpPr/>
+          <p:nvPr/>
+        </p:nvSpPr>
+        <p:spPr>
+          <a:xfrm>
+            <a:off x="2103120" y="2697480"/>
+            <a:ext cx="2194560" cy="713232"/>
+          </a:xfrm>
+          <a:prstGeom prst="rect">
+            <a:avLst/>
+          </a:prstGeom>
+          <a:solidFill>
+            <a:srgbClr val="F5F1E8"/>
+          </a:solidFill>
+          <a:ln w="12700">
+            <a:solidFill>
+              <a:srgbClr val="C9B991"/>
+            </a:solidFill>
+          </a:ln>
+          <a:effectLst/>
+        </p:spPr>
+        <p:style>
+          <a:lnRef idx="1">
+            <a:schemeClr val="accent1"/>
+          </a:lnRef>
+          <a:fillRef idx="3">
+            <a:schemeClr val="accent1"/>
+          </a:fillRef>
+          <a:effectRef idx="2">
+            <a:schemeClr val="accent1"/>
+          </a:effectRef>
+          <a:fontRef idx="minor">
+            <a:schemeClr val="lt1"/>
+          </a:fontRef>
+        </p:style>
+        <p:txBody>
+          <a:bodyPr wrap="square" lIns="27432" tIns="22860" rIns="27432" bIns="22860" rtlCol="0" anchor="ctr"/>
+          <a:lstStyle/>
+          <a:p>
+            <a:pPr algn="ctr"/>
+            <a:r>
+              <a:rPr sz="1100" b="0" i="1">
+                <a:solidFill>
+                  <a:srgbClr val="5C4826"/>
+                </a:solidFill>
+              </a:rPr>
+              <a:t>a defect escapes testing</a:t>
+            </a:r>
+          </a:p>
+        </p:txBody>
+      </p:sp>
+      <p:sp>
+        <p:nvSpPr>
+          <p:cNvPr id="909" name="Block"/>
+          <p:cNvSpPr/>
+          <p:nvPr/>
+        </p:nvSpPr>
+        <p:spPr>
+          <a:xfrm>
+            <a:off x="365760" y="1920240"/>
+            <a:ext cx="1645920" cy="713232"/>
+          </a:xfrm>
+          <a:prstGeom prst="rect">
+            <a:avLst/>
+          </a:prstGeom>
+          <a:solidFill>
+            <a:srgbClr val="8E6F3E"/>
+          </a:solidFill>
+          <a:ln>
+            <a:noFill/>
+          </a:ln>
+          <a:effectLst/>
+        </p:spPr>
+        <p:style>
+          <a:lnRef idx="1">
+            <a:schemeClr val="accent1"/>
+          </a:lnRef>
+          <a:fillRef idx="3">
+            <a:schemeClr val="accent1"/>
+          </a:fillRef>
+          <a:effectRef idx="2">
+            <a:schemeClr val="accent1"/>
+          </a:effectRef>
+          <a:fontRef idx="minor">
+            <a:schemeClr val="lt1"/>
+          </a:fontRef>
+        </p:style>
+        <p:txBody>
+          <a:bodyPr wrap="square" lIns="27432" tIns="22860" rIns="27432" bIns="22860" rtlCol="0" anchor="ctr"/>
+          <a:lstStyle/>
+          <a:p>
+            <a:pPr algn="ctr"/>
+            <a:r>
+              <a:rPr sz="1200" b="1" i="0" dirty="0">
+                <a:solidFill>
+                  <a:srgbClr val="FFFFFF"/>
+                </a:solidFill>
+              </a:rPr>
+              <a:t>Interpret security content</a:t>
+            </a:r>
+            <a:endParaRPr lang="en-US" sz="2000" b="1" i="0" dirty="0">
+              <a:solidFill>
+                <a:srgbClr val="FFFFFF"/>
+              </a:solidFill>
+            </a:endParaRPr>
+          </a:p>
+        </p:txBody>
+      </p:sp>
+      <p:sp>
+        <p:nvSpPr>
+          <p:cNvPr id="910" name="Block"/>
+          <p:cNvSpPr/>
+          <p:nvPr/>
+        </p:nvSpPr>
+        <p:spPr>
+          <a:xfrm>
+            <a:off x="365760" y="2697480"/>
+            <a:ext cx="1645920" cy="713232"/>
+          </a:xfrm>
+          <a:prstGeom prst="rect">
+            <a:avLst/>
+          </a:prstGeom>
+          <a:solidFill>
+            <a:srgbClr val="8E6F3E"/>
+          </a:solidFill>
+          <a:ln>
+            <a:noFill/>
+          </a:ln>
+          <a:effectLst/>
+        </p:spPr>
+        <p:style>
+          <a:lnRef idx="1">
+            <a:schemeClr val="accent1"/>
+          </a:lnRef>
+          <a:fillRef idx="3">
+            <a:schemeClr val="accent1"/>
+          </a:fillRef>
+          <a:effectRef idx="2">
+            <a:schemeClr val="accent1"/>
+          </a:effectRef>
+          <a:fontRef idx="minor">
+            <a:schemeClr val="lt1"/>
+          </a:fontRef>
+        </p:style>
+        <p:txBody>
+          <a:bodyPr wrap="square" lIns="27432" tIns="22860" rIns="27432" bIns="22860" rtlCol="0" anchor="ctr"/>
+          <a:lstStyle/>
+          <a:p>
+            <a:pPr algn="ctr"/>
+            <a:r>
+              <a:rPr sz="1200" b="1" i="0" dirty="0">
+                <a:solidFill>
+                  <a:srgbClr val="FFFFFF"/>
+                </a:solidFill>
+              </a:rPr>
+              <a:t>Validate content</a:t>
+            </a:r>
+            <a:endParaRPr lang="en-US" sz="2000" b="1" i="0" dirty="0">
+              <a:solidFill>
+                <a:srgbClr val="FFFFFF"/>
+              </a:solidFill>
+            </a:endParaRPr>
+          </a:p>
+        </p:txBody>
+      </p:sp>
+      <p:sp>
+        <p:nvSpPr>
+          <p:cNvPr id="911" name="Block"/>
+          <p:cNvSpPr/>
+          <p:nvPr/>
+        </p:nvSpPr>
+        <p:spPr>
+          <a:xfrm>
+            <a:off x="365760" y="3474720"/>
+            <a:ext cx="1645920" cy="713232"/>
+          </a:xfrm>
+          <a:prstGeom prst="rect">
+            <a:avLst/>
+          </a:prstGeom>
+          <a:solidFill>
+            <a:srgbClr val="8E6F3E"/>
+          </a:solidFill>
+          <a:ln>
+            <a:noFill/>
+          </a:ln>
+          <a:effectLst/>
+        </p:spPr>
+        <p:style>
+          <a:lnRef idx="1">
+            <a:schemeClr val="accent1"/>
+          </a:lnRef>
+          <a:fillRef idx="3">
+            <a:schemeClr val="accent1"/>
+          </a:fillRef>
+          <a:effectRef idx="2">
+            <a:schemeClr val="accent1"/>
+          </a:effectRef>
+          <a:fontRef idx="minor">
+            <a:schemeClr val="lt1"/>
+          </a:fontRef>
+        </p:style>
+        <p:txBody>
+          <a:bodyPr wrap="square" lIns="27432" tIns="22860" rIns="27432" bIns="22860" rtlCol="0" anchor="ctr"/>
+          <a:lstStyle/>
+          <a:p>
+            <a:pPr algn="ctr"/>
+            <a:r>
+              <a:rPr sz="1200" b="1" i="0" dirty="0">
+                <a:solidFill>
+                  <a:srgbClr val="FFFFFF"/>
+                </a:solidFill>
+              </a:rPr>
+              <a:t>Distribute content</a:t>
+            </a:r>
+            <a:endParaRPr sz="2000" b="1" i="0" dirty="0">
+              <a:solidFill>
+                <a:srgbClr val="FFFFFF"/>
+              </a:solidFill>
+            </a:endParaRPr>
+          </a:p>
+        </p:txBody>
+      </p:sp>
+      <p:sp>
+        <p:nvSpPr>
+          <p:cNvPr id="912" name="Block"/>
+          <p:cNvSpPr/>
+          <p:nvPr/>
+        </p:nvSpPr>
+        <p:spPr>
+          <a:xfrm>
+            <a:off x="365760" y="4251960"/>
+            <a:ext cx="1645920" cy="713232"/>
+          </a:xfrm>
+          <a:prstGeom prst="rect">
+            <a:avLst/>
+          </a:prstGeom>
+          <a:solidFill>
+            <a:srgbClr val="8E6F3E"/>
+          </a:solidFill>
+          <a:ln>
+            <a:noFill/>
+          </a:ln>
+          <a:effectLst/>
+        </p:spPr>
+        <p:style>
+          <a:lnRef idx="1">
+            <a:schemeClr val="accent1"/>
+          </a:lnRef>
+          <a:fillRef idx="3">
+            <a:schemeClr val="accent1"/>
+          </a:fillRef>
+          <a:effectRef idx="2">
+            <a:schemeClr val="accent1"/>
+          </a:effectRef>
+          <a:fontRef idx="minor">
+            <a:schemeClr val="lt1"/>
+          </a:fontRef>
+        </p:style>
+        <p:txBody>
+          <a:bodyPr wrap="square" lIns="27432" tIns="22860" rIns="27432" bIns="22860" rtlCol="0" anchor="ctr"/>
+          <a:lstStyle/>
+          <a:p>
+            <a:pPr algn="ctr"/>
+            <a:r>
+              <a:rPr sz="1200" b="1" i="0" dirty="0">
+                <a:solidFill>
+                  <a:srgbClr val="FFFFFF"/>
+                </a:solidFill>
+              </a:rPr>
+              <a:t>Maintain service</a:t>
+            </a:r>
+          </a:p>
+        </p:txBody>
+      </p:sp>
+      <p:sp>
+        <p:nvSpPr>
+          <p:cNvPr id="913" name="FooterBand"/>
+          <p:cNvSpPr/>
+          <p:nvPr/>
+        </p:nvSpPr>
+        <p:spPr>
+          <a:xfrm>
+            <a:off x="274320" y="5852160"/>
+            <a:ext cx="8595360" cy="566928"/>
+          </a:xfrm>
+          <a:prstGeom prst="rect">
+            <a:avLst/>
+          </a:prstGeom>
+          <a:noFill/>
+          <a:ln>
+            <a:noFill/>
+          </a:ln>
+          <a:effectLst/>
+        </p:spPr>
+        <p:style>
+          <a:lnRef idx="1">
+            <a:schemeClr val="accent1"/>
+          </a:lnRef>
+          <a:fillRef idx="3">
+            <a:schemeClr val="accent1"/>
+          </a:fillRef>
+          <a:effectRef idx="2">
+            <a:schemeClr val="accent1"/>
+          </a:effectRef>
+          <a:fontRef idx="minor">
+            <a:schemeClr val="lt1"/>
+          </a:fontRef>
+        </p:style>
+        <p:txBody>
+          <a:bodyPr wrap="square" lIns="27432" tIns="22860" rIns="27432" bIns="22860" rtlCol="0" anchor="ctr"/>
+          <a:lstStyle/>
+          <a:p>
+            <a:pPr algn="ctr"/>
+            <a:r>
+              <a:rPr lang="en-US" sz="2000" b="1" i="0" dirty="0">
+                <a:solidFill>
+                  <a:schemeClr val="bg1"/>
+                </a:solidFill>
+              </a:rPr>
+              <a:t>Which of these failure modes could occur in another security product?</a:t>
+            </a:r>
+          </a:p>
+        </p:txBody>
+      </p:sp>
+      <p:sp>
+        <p:nvSpPr>
+          <p:cNvPr id="2" name="Card"/>
+          <p:cNvSpPr/>
+          <p:nvPr/>
+        </p:nvSpPr>
+        <p:spPr>
+          <a:xfrm>
+            <a:off x="2103120" y="3474720"/>
+            <a:ext cx="2194560" cy="713232"/>
+          </a:xfrm>
+          <a:prstGeom prst="rect">
+            <a:avLst/>
+          </a:prstGeom>
+          <a:solidFill>
+            <a:srgbClr val="F5F1E8"/>
+          </a:solidFill>
+          <a:ln w="12700">
+            <a:solidFill>
+              <a:srgbClr val="C9B991"/>
+            </a:solidFill>
+          </a:ln>
+          <a:effectLst/>
+        </p:spPr>
+        <p:style>
+          <a:lnRef idx="1">
+            <a:schemeClr val="accent1"/>
+          </a:lnRef>
+          <a:fillRef idx="3">
+            <a:schemeClr val="accent1"/>
+          </a:fillRef>
+          <a:effectRef idx="2">
+            <a:schemeClr val="accent1"/>
+          </a:effectRef>
+          <a:fontRef idx="minor">
+            <a:schemeClr val="lt1"/>
+          </a:fontRef>
+        </p:style>
+        <p:txBody>
+          <a:bodyPr wrap="square" lIns="27432" tIns="22860" rIns="27432" bIns="22860" rtlCol="0" anchor="ctr"/>
+          <a:lstStyle/>
+          <a:p>
+            <a:pPr algn="ctr"/>
+            <a:r>
+              <a:rPr lang="en-US" sz="1100" b="0" i="1" dirty="0">
+                <a:solidFill>
+                  <a:srgbClr val="5C4826"/>
+                </a:solidFill>
+              </a:rPr>
+              <a:t>a defective update reaches all endpoints</a:t>
+            </a:r>
+          </a:p>
+        </p:txBody>
+      </p:sp>
+      <p:sp>
+        <p:nvSpPr>
+          <p:cNvPr id="4" name="Card"/>
+          <p:cNvSpPr/>
+          <p:nvPr/>
+        </p:nvSpPr>
+        <p:spPr>
+          <a:xfrm>
+            <a:off x="2103120" y="4251960"/>
+            <a:ext cx="2194560" cy="713232"/>
+          </a:xfrm>
+          <a:prstGeom prst="rect">
+            <a:avLst/>
+          </a:prstGeom>
+          <a:solidFill>
+            <a:srgbClr val="F5F1E8"/>
+          </a:solidFill>
+          <a:ln w="12700">
+            <a:solidFill>
+              <a:srgbClr val="C9B991"/>
+            </a:solidFill>
+          </a:ln>
+          <a:effectLst/>
+        </p:spPr>
+        <p:style>
+          <a:lnRef idx="1">
+            <a:schemeClr val="accent1"/>
+          </a:lnRef>
+          <a:fillRef idx="3">
+            <a:schemeClr val="accent1"/>
+          </a:fillRef>
+          <a:effectRef idx="2">
+            <a:schemeClr val="accent1"/>
+          </a:effectRef>
+          <a:fontRef idx="minor">
+            <a:schemeClr val="lt1"/>
+          </a:fontRef>
+        </p:style>
+        <p:txBody>
+          <a:bodyPr wrap="square" lIns="27432" tIns="22860" rIns="27432" bIns="22860" rtlCol="0" anchor="ctr"/>
+          <a:lstStyle/>
+          <a:p>
+            <a:pPr algn="ctr"/>
+            <a:r>
+              <a:rPr lang="en-US" sz="1100" b="0" i="1" dirty="0">
+                <a:solidFill>
+                  <a:srgbClr val="5C4826"/>
+                </a:solidFill>
+              </a:rPr>
+              <a:t>endpoint failure disables critical services</a:t>
+            </a:r>
+            <a:endParaRPr sz="2000" b="0" i="1" dirty="0">
+              <a:solidFill>
+                <a:srgbClr val="5C4826"/>
+              </a:solidFill>
+            </a:endParaRPr>
+          </a:p>
+        </p:txBody>
+      </p:sp>
+      <p:sp>
+        <p:nvSpPr>
+          <p:cNvPr id="5" name="ColumnHeading"/>
+          <p:cNvSpPr/>
+          <p:nvPr/>
+        </p:nvSpPr>
+        <p:spPr>
+          <a:xfrm>
+            <a:off x="365760" y="1572768"/>
+            <a:ext cx="1645920" cy="274320"/>
+          </a:xfrm>
+          <a:prstGeom prst="rect">
+            <a:avLst/>
+          </a:prstGeom>
+          <a:noFill/>
+          <a:ln>
+            <a:noFill/>
+          </a:ln>
+          <a:effectLst/>
+        </p:spPr>
+        <p:style>
+          <a:lnRef idx="1">
+            <a:schemeClr val="accent1"/>
+          </a:lnRef>
+          <a:fillRef idx="3">
+            <a:schemeClr val="accent1"/>
+          </a:fillRef>
+          <a:effectRef idx="2">
+            <a:schemeClr val="accent1"/>
+          </a:effectRef>
+          <a:fontRef idx="minor">
+            <a:schemeClr val="lt1"/>
+          </a:fontRef>
+        </p:style>
+        <p:txBody>
+          <a:bodyPr wrap="square" lIns="27432" tIns="22860" rIns="27432" bIns="22860" rtlCol="0" anchor="ctr"/>
+          <a:lstStyle/>
+          <a:p>
+            <a:pPr algn="ctr"/>
+            <a:r>
+              <a:rPr lang="en-US" sz="1200" b="1" i="0" dirty="0">
+                <a:solidFill>
+                  <a:schemeClr val="bg1"/>
+                </a:solidFill>
+              </a:rPr>
+              <a:t>FUNCTION</a:t>
+            </a:r>
+            <a:endParaRPr sz="2800" b="1" i="0" dirty="0">
+              <a:solidFill>
+                <a:schemeClr val="bg1"/>
+              </a:solidFill>
+            </a:endParaRPr>
+          </a:p>
+        </p:txBody>
+      </p:sp>
+      <p:sp>
+        <p:nvSpPr>
+          <p:cNvPr id="6" name="ColumnHeading"/>
+          <p:cNvSpPr/>
+          <p:nvPr/>
+        </p:nvSpPr>
+        <p:spPr>
+          <a:xfrm>
+            <a:off x="2103120" y="1572768"/>
+            <a:ext cx="2194560" cy="274320"/>
+          </a:xfrm>
+          <a:prstGeom prst="rect">
+            <a:avLst/>
+          </a:prstGeom>
+          <a:noFill/>
+          <a:ln>
+            <a:noFill/>
+          </a:ln>
+          <a:effectLst/>
+        </p:spPr>
+        <p:style>
+          <a:lnRef idx="1">
+            <a:schemeClr val="accent1"/>
+          </a:lnRef>
+          <a:fillRef idx="3">
+            <a:schemeClr val="accent1"/>
+          </a:fillRef>
+          <a:effectRef idx="2">
+            <a:schemeClr val="accent1"/>
+          </a:effectRef>
+          <a:fontRef idx="minor">
+            <a:schemeClr val="lt1"/>
+          </a:fontRef>
+        </p:style>
+        <p:txBody>
+          <a:bodyPr wrap="square" lIns="27432" tIns="22860" rIns="27432" bIns="22860" rtlCol="0" anchor="ctr"/>
+          <a:lstStyle/>
+          <a:p>
+            <a:pPr algn="ctr"/>
+            <a:r>
+              <a:rPr lang="en-US" sz="1200" b="1" i="0" dirty="0">
+                <a:solidFill>
+                  <a:schemeClr val="bg1"/>
+                </a:solidFill>
+              </a:rPr>
+              <a:t>FAILURE MODE</a:t>
+            </a:r>
+            <a:endParaRPr sz="2800" b="1" i="0" dirty="0">
+              <a:solidFill>
+                <a:schemeClr val="bg1"/>
+              </a:solidFill>
+            </a:endParaRPr>
+          </a:p>
+        </p:txBody>
+      </p:sp>
+      <p:sp>
+        <p:nvSpPr>
+          <p:cNvPr id="915" name="Label"/>
+          <p:cNvSpPr txBox="1"/>
+          <p:nvPr/>
+        </p:nvSpPr>
+        <p:spPr>
+          <a:xfrm>
+            <a:off x="548640" y="841248"/>
+            <a:ext cx="8046720" cy="566928"/>
+          </a:xfrm>
+          <a:prstGeom prst="rect">
+            <a:avLst/>
+          </a:prstGeom>
+          <a:noFill/>
+        </p:spPr>
+        <p:txBody>
+          <a:bodyPr wrap="square" lIns="27432" tIns="22860" rIns="27432" bIns="22860" anchor="t">
+            <a:spAutoFit/>
+          </a:bodyPr>
+          <a:lstStyle/>
+          <a:p>
+            <a:pPr algn="ctr"/>
+            <a:r>
+              <a:rPr sz="1200" b="1" i="1">
+                <a:solidFill>
+                  <a:srgbClr val="5C4826"/>
+                </a:solidFill>
+              </a:rPr>
+              <a:t>The three models explain a failure that has happened. FMEA — Failure Mode and Effects Analysis —</a:t>
+            </a:r>
+          </a:p>
+          <a:p>
+            <a:pPr algn="ctr"/>
+            <a:r>
+              <a:rPr sz="1200" b="1" i="1">
+                <a:solidFill>
+                  <a:srgbClr val="5C4826"/>
+                </a:solidFill>
+              </a:rPr>
+              <a:t>searches for failures that have not happened yet: function by function, what could fail, with what effect, held by which control?</a:t>
+            </a:r>
+          </a:p>
+        </p:txBody>
+      </p:sp>
+      <p:sp>
+        <p:nvSpPr>
+          <p:cNvPr id="1000" name="ColumnHeading"/>
+          <p:cNvSpPr/>
+          <p:nvPr/>
+        </p:nvSpPr>
+        <p:spPr>
+          <a:xfrm>
+            <a:off x="4389120" y="1572768"/>
+            <a:ext cx="1828800" cy="274320"/>
+          </a:xfrm>
+          <a:prstGeom prst="rect">
+            <a:avLst/>
+          </a:prstGeom>
+          <a:noFill/>
+          <a:ln>
+            <a:noFill/>
+          </a:ln>
+          <a:effectLst/>
+        </p:spPr>
+        <p:style>
+          <a:lnRef idx="1">
+            <a:schemeClr val="accent1"/>
+          </a:lnRef>
+          <a:fillRef idx="3">
+            <a:schemeClr val="accent1"/>
+          </a:fillRef>
+          <a:effectRef idx="2">
+            <a:schemeClr val="accent1"/>
+          </a:effectRef>
+          <a:fontRef idx="minor">
+            <a:schemeClr val="lt1"/>
+          </a:fontRef>
+        </p:style>
+        <p:txBody>
+          <a:bodyPr wrap="square" lIns="27432" tIns="22860" rIns="27432" bIns="22860" rtlCol="0" anchor="ctr"/>
+          <a:lstStyle/>
+          <a:p>
+            <a:pPr algn="ctr"/>
+            <a:r>
+              <a:rPr lang="en-US" sz="1200" b="1" i="0" dirty="0">
+                <a:solidFill>
+                  <a:schemeClr val="bg1"/>
+                </a:solidFill>
+              </a:rPr>
+              <a:t>EFFECT</a:t>
+            </a:r>
+            <a:endParaRPr sz="2800" b="1" i="0" dirty="0">
+              <a:solidFill>
+                <a:schemeClr val="bg1"/>
+              </a:solidFill>
+            </a:endParaRPr>
+          </a:p>
+        </p:txBody>
+      </p:sp>
+      <p:sp>
+        <p:nvSpPr>
+          <p:cNvPr id="1001" name="ColumnHeading"/>
+          <p:cNvSpPr/>
+          <p:nvPr/>
+        </p:nvSpPr>
+        <p:spPr>
+          <a:xfrm>
+            <a:off x="6309360" y="1572768"/>
+            <a:ext cx="2286000" cy="274320"/>
+          </a:xfrm>
+          <a:prstGeom prst="rect">
+            <a:avLst/>
+          </a:prstGeom>
+          <a:noFill/>
+          <a:ln>
+            <a:noFill/>
+          </a:ln>
+          <a:effectLst/>
+        </p:spPr>
+        <p:style>
+          <a:lnRef idx="1">
+            <a:schemeClr val="accent1"/>
+          </a:lnRef>
+          <a:fillRef idx="3">
+            <a:schemeClr val="accent1"/>
+          </a:fillRef>
+          <a:effectRef idx="2">
+            <a:schemeClr val="accent1"/>
+          </a:effectRef>
+          <a:fontRef idx="minor">
+            <a:schemeClr val="lt1"/>
+          </a:fontRef>
+        </p:style>
+        <p:txBody>
+          <a:bodyPr wrap="square" lIns="27432" tIns="22860" rIns="27432" bIns="22860" rtlCol="0" anchor="ctr"/>
+          <a:lstStyle/>
+          <a:p>
+            <a:pPr algn="ctr"/>
+            <a:r>
+              <a:rPr lang="en-US" sz="1200" b="1" i="0" dirty="0">
+                <a:solidFill>
+                  <a:schemeClr val="bg1"/>
+                </a:solidFill>
+              </a:rPr>
+              <a:t>CANDIDATE CONTROL</a:t>
+            </a:r>
+            <a:endParaRPr sz="2800" b="1" i="0" dirty="0">
+              <a:solidFill>
+                <a:schemeClr val="bg1"/>
+              </a:solidFill>
+            </a:endParaRPr>
+          </a:p>
+        </p:txBody>
+      </p:sp>
+      <p:sp>
+        <p:nvSpPr>
+          <p:cNvPr id="1002" name="Card"/>
+          <p:cNvSpPr/>
+          <p:nvPr/>
+        </p:nvSpPr>
+        <p:spPr>
+          <a:xfrm>
+            <a:off x="4389120" y="1920240"/>
+            <a:ext cx="1828800" cy="713232"/>
+          </a:xfrm>
+          <a:prstGeom prst="rect">
+            <a:avLst/>
+          </a:prstGeom>
+          <a:solidFill>
+            <a:srgbClr val="F5F1E8"/>
+          </a:solidFill>
+          <a:ln w="12700">
+            <a:solidFill>
+              <a:srgbClr val="C9B991"/>
+            </a:solidFill>
+          </a:ln>
+          <a:effectLst/>
+        </p:spPr>
+        <p:style>
+          <a:lnRef idx="1">
+            <a:schemeClr val="accent1"/>
+          </a:lnRef>
+          <a:fillRef idx="3">
+            <a:schemeClr val="accent1"/>
+          </a:fillRef>
+          <a:effectRef idx="2">
+            <a:schemeClr val="accent1"/>
+          </a:effectRef>
+          <a:fontRef idx="minor">
+            <a:schemeClr val="lt1"/>
+          </a:fontRef>
+        </p:style>
+        <p:txBody>
+          <a:bodyPr wrap="square" lIns="27432" tIns="22860" rIns="27432" bIns="22860" rtlCol="0" anchor="ctr"/>
+          <a:lstStyle/>
+          <a:p>
+            <a:pPr algn="ctr"/>
+            <a:r>
+              <a:rPr sz="1100" b="0" i="1" dirty="0">
+                <a:solidFill>
+                  <a:srgbClr val="5C4826"/>
+                </a:solidFill>
+              </a:rPr>
+              <a:t>endpoint failure</a:t>
+            </a:r>
+          </a:p>
+        </p:txBody>
+      </p:sp>
+      <p:sp>
+        <p:nvSpPr>
+          <p:cNvPr id="1003" name="Card"/>
+          <p:cNvSpPr/>
+          <p:nvPr/>
+        </p:nvSpPr>
+        <p:spPr>
+          <a:xfrm>
+            <a:off x="6309360" y="1920240"/>
+            <a:ext cx="2286000" cy="713232"/>
+          </a:xfrm>
+          <a:prstGeom prst="rect">
+            <a:avLst/>
+          </a:prstGeom>
+          <a:solidFill>
+            <a:srgbClr val="F5F1E8"/>
+          </a:solidFill>
+          <a:ln w="12700">
+            <a:solidFill>
+              <a:srgbClr val="C9B991"/>
+            </a:solidFill>
+          </a:ln>
+          <a:effectLst/>
+        </p:spPr>
+        <p:style>
+          <a:lnRef idx="1">
+            <a:schemeClr val="accent1"/>
+          </a:lnRef>
+          <a:fillRef idx="3">
+            <a:schemeClr val="accent1"/>
+          </a:fillRef>
+          <a:effectRef idx="2">
+            <a:schemeClr val="accent1"/>
+          </a:effectRef>
+          <a:fontRef idx="minor">
+            <a:schemeClr val="lt1"/>
+          </a:fontRef>
+        </p:style>
+        <p:txBody>
+          <a:bodyPr wrap="square" lIns="27432" tIns="22860" rIns="27432" bIns="22860" rtlCol="0" anchor="ctr"/>
+          <a:lstStyle/>
+          <a:p>
+            <a:pPr algn="ctr"/>
+            <a:r>
+              <a:rPr sz="1100" b="0" i="1" dirty="0">
+                <a:solidFill>
+                  <a:srgbClr val="5C4826"/>
+                </a:solidFill>
+              </a:rPr>
+              <a:t>contract validation</a:t>
+            </a:r>
+          </a:p>
+        </p:txBody>
+      </p:sp>
+      <p:sp>
+        <p:nvSpPr>
+          <p:cNvPr id="1004" name="Card"/>
+          <p:cNvSpPr/>
+          <p:nvPr/>
+        </p:nvSpPr>
+        <p:spPr>
+          <a:xfrm>
+            <a:off x="4389120" y="2697480"/>
+            <a:ext cx="1828800" cy="713232"/>
+          </a:xfrm>
+          <a:prstGeom prst="rect">
+            <a:avLst/>
+          </a:prstGeom>
+          <a:solidFill>
+            <a:srgbClr val="F5F1E8"/>
+          </a:solidFill>
+          <a:ln w="12700">
+            <a:solidFill>
+              <a:srgbClr val="C9B991"/>
+            </a:solidFill>
+          </a:ln>
+          <a:effectLst/>
+        </p:spPr>
+        <p:style>
+          <a:lnRef idx="1">
+            <a:schemeClr val="accent1"/>
+          </a:lnRef>
+          <a:fillRef idx="3">
+            <a:schemeClr val="accent1"/>
+          </a:fillRef>
+          <a:effectRef idx="2">
+            <a:schemeClr val="accent1"/>
+          </a:effectRef>
+          <a:fontRef idx="minor">
+            <a:schemeClr val="lt1"/>
+          </a:fontRef>
+        </p:style>
+        <p:txBody>
+          <a:bodyPr wrap="square" lIns="27432" tIns="22860" rIns="27432" bIns="22860" rtlCol="0" anchor="ctr"/>
+          <a:lstStyle/>
+          <a:p>
+            <a:pPr algn="ctr"/>
+            <a:r>
+              <a:rPr sz="1100" b="0" i="1" dirty="0">
+                <a:solidFill>
+                  <a:srgbClr val="5C4826"/>
+                </a:solidFill>
+              </a:rPr>
+              <a:t>defective update released</a:t>
+            </a:r>
+          </a:p>
+        </p:txBody>
+      </p:sp>
+      <p:sp>
+        <p:nvSpPr>
+          <p:cNvPr id="1005" name="Card"/>
+          <p:cNvSpPr/>
+          <p:nvPr/>
+        </p:nvSpPr>
+        <p:spPr>
+          <a:xfrm>
+            <a:off x="6309360" y="2697480"/>
+            <a:ext cx="2286000" cy="713232"/>
+          </a:xfrm>
+          <a:prstGeom prst="rect">
+            <a:avLst/>
+          </a:prstGeom>
+          <a:solidFill>
+            <a:srgbClr val="F5F1E8"/>
+          </a:solidFill>
+          <a:ln w="12700">
+            <a:solidFill>
+              <a:srgbClr val="C9B991"/>
+            </a:solidFill>
+          </a:ln>
+          <a:effectLst/>
+        </p:spPr>
+        <p:style>
+          <a:lnRef idx="1">
+            <a:schemeClr val="accent1"/>
+          </a:lnRef>
+          <a:fillRef idx="3">
+            <a:schemeClr val="accent1"/>
+          </a:fillRef>
+          <a:effectRef idx="2">
+            <a:schemeClr val="accent1"/>
+          </a:effectRef>
+          <a:fontRef idx="minor">
+            <a:schemeClr val="lt1"/>
+          </a:fontRef>
+        </p:style>
+        <p:txBody>
+          <a:bodyPr wrap="square" lIns="27432" tIns="22860" rIns="27432" bIns="22860" rtlCol="0" anchor="ctr"/>
+          <a:lstStyle/>
+          <a:p>
+            <a:pPr algn="ctr"/>
+            <a:r>
+              <a:rPr sz="1100" b="0" i="1" dirty="0">
+                <a:solidFill>
+                  <a:srgbClr val="5C4826"/>
+                </a:solidFill>
+              </a:rPr>
+              <a:t>independent compatibility tests</a:t>
+            </a:r>
+          </a:p>
+        </p:txBody>
+      </p:sp>
+      <p:sp>
+        <p:nvSpPr>
+          <p:cNvPr id="1006" name="Card"/>
+          <p:cNvSpPr/>
+          <p:nvPr/>
+        </p:nvSpPr>
+        <p:spPr>
+          <a:xfrm>
+            <a:off x="4389120" y="3474720"/>
+            <a:ext cx="1828800" cy="713232"/>
+          </a:xfrm>
+          <a:prstGeom prst="rect">
+            <a:avLst/>
+          </a:prstGeom>
+          <a:solidFill>
+            <a:srgbClr val="F5F1E8"/>
+          </a:solidFill>
+          <a:ln w="12700">
+            <a:solidFill>
+              <a:srgbClr val="C9B991"/>
+            </a:solidFill>
+          </a:ln>
+          <a:effectLst/>
+        </p:spPr>
+        <p:style>
+          <a:lnRef idx="1">
+            <a:schemeClr val="accent1"/>
+          </a:lnRef>
+          <a:fillRef idx="3">
+            <a:schemeClr val="accent1"/>
+          </a:fillRef>
+          <a:effectRef idx="2">
+            <a:schemeClr val="accent1"/>
+          </a:effectRef>
+          <a:fontRef idx="minor">
+            <a:schemeClr val="lt1"/>
+          </a:fontRef>
+        </p:style>
+        <p:txBody>
+          <a:bodyPr wrap="square" lIns="27432" tIns="22860" rIns="27432" bIns="22860" rtlCol="0" anchor="ctr"/>
+          <a:lstStyle/>
+          <a:p>
+            <a:pPr algn="ctr"/>
+            <a:r>
+              <a:rPr sz="1100" b="0" i="1" dirty="0">
+                <a:solidFill>
+                  <a:srgbClr val="5C4826"/>
+                </a:solidFill>
+              </a:rPr>
+              <a:t>widespread outage</a:t>
+            </a:r>
+          </a:p>
+        </p:txBody>
+      </p:sp>
+      <p:sp>
+        <p:nvSpPr>
+          <p:cNvPr id="1007" name="Card"/>
+          <p:cNvSpPr/>
+          <p:nvPr/>
+        </p:nvSpPr>
+        <p:spPr>
+          <a:xfrm>
+            <a:off x="6309360" y="3474720"/>
+            <a:ext cx="2286000" cy="713232"/>
+          </a:xfrm>
+          <a:prstGeom prst="rect">
+            <a:avLst/>
+          </a:prstGeom>
+          <a:solidFill>
+            <a:srgbClr val="F5F1E8"/>
+          </a:solidFill>
+          <a:ln w="12700">
+            <a:solidFill>
+              <a:srgbClr val="C9B991"/>
+            </a:solidFill>
+          </a:ln>
+          <a:effectLst/>
+        </p:spPr>
+        <p:style>
+          <a:lnRef idx="1">
+            <a:schemeClr val="accent1"/>
+          </a:lnRef>
+          <a:fillRef idx="3">
+            <a:schemeClr val="accent1"/>
+          </a:fillRef>
+          <a:effectRef idx="2">
+            <a:schemeClr val="accent1"/>
+          </a:effectRef>
+          <a:fontRef idx="minor">
+            <a:schemeClr val="lt1"/>
+          </a:fontRef>
+        </p:style>
+        <p:txBody>
+          <a:bodyPr wrap="square" lIns="27432" tIns="22860" rIns="27432" bIns="22860" rtlCol="0" anchor="ctr"/>
+          <a:lstStyle/>
+          <a:p>
+            <a:pPr algn="ctr"/>
+            <a:r>
+              <a:rPr sz="1100" b="0" i="1" dirty="0">
+                <a:solidFill>
+                  <a:srgbClr val="5C4826"/>
+                </a:solidFill>
+              </a:rPr>
+              <a:t>staged rollout + demonstrated halt</a:t>
+            </a:r>
+          </a:p>
+        </p:txBody>
+      </p:sp>
+      <p:sp>
+        <p:nvSpPr>
+          <p:cNvPr id="1008" name="Card"/>
+          <p:cNvSpPr/>
+          <p:nvPr/>
+        </p:nvSpPr>
+        <p:spPr>
+          <a:xfrm>
+            <a:off x="4389120" y="4251960"/>
+            <a:ext cx="1828800" cy="713232"/>
+          </a:xfrm>
+          <a:prstGeom prst="rect">
+            <a:avLst/>
+          </a:prstGeom>
+          <a:solidFill>
+            <a:srgbClr val="F5F1E8"/>
+          </a:solidFill>
+          <a:ln w="12700">
+            <a:solidFill>
+              <a:srgbClr val="C9B991"/>
+            </a:solidFill>
+          </a:ln>
+          <a:effectLst/>
+        </p:spPr>
+        <p:style>
+          <a:lnRef idx="1">
+            <a:schemeClr val="accent1"/>
+          </a:lnRef>
+          <a:fillRef idx="3">
+            <a:schemeClr val="accent1"/>
+          </a:fillRef>
+          <a:effectRef idx="2">
+            <a:schemeClr val="accent1"/>
+          </a:effectRef>
+          <a:fontRef idx="minor">
+            <a:schemeClr val="lt1"/>
+          </a:fontRef>
+        </p:style>
+        <p:txBody>
+          <a:bodyPr wrap="square" lIns="27432" tIns="22860" rIns="27432" bIns="22860" rtlCol="0" anchor="ctr"/>
+          <a:lstStyle/>
+          <a:p>
+            <a:pPr algn="ctr"/>
+            <a:r>
+              <a:rPr sz="1100" b="0" i="1" dirty="0">
+                <a:solidFill>
+                  <a:srgbClr val="5C4826"/>
+                </a:solidFill>
+              </a:rPr>
+              <a:t>service disruption</a:t>
+            </a:r>
+          </a:p>
+        </p:txBody>
+      </p:sp>
+      <p:sp>
+        <p:nvSpPr>
+          <p:cNvPr id="1009" name="Card"/>
+          <p:cNvSpPr/>
+          <p:nvPr/>
+        </p:nvSpPr>
+        <p:spPr>
+          <a:xfrm>
+            <a:off x="6309360" y="4251960"/>
+            <a:ext cx="2286000" cy="713232"/>
+          </a:xfrm>
+          <a:prstGeom prst="rect">
+            <a:avLst/>
+          </a:prstGeom>
+          <a:solidFill>
+            <a:srgbClr val="F5F1E8"/>
+          </a:solidFill>
+          <a:ln w="12700">
+            <a:solidFill>
+              <a:srgbClr val="C9B991"/>
+            </a:solidFill>
+          </a:ln>
+          <a:effectLst/>
+        </p:spPr>
+        <p:style>
+          <a:lnRef idx="1">
+            <a:schemeClr val="accent1"/>
+          </a:lnRef>
+          <a:fillRef idx="3">
+            <a:schemeClr val="accent1"/>
+          </a:fillRef>
+          <a:effectRef idx="2">
+            <a:schemeClr val="accent1"/>
+          </a:effectRef>
+          <a:fontRef idx="minor">
+            <a:schemeClr val="lt1"/>
+          </a:fontRef>
+        </p:style>
+        <p:txBody>
+          <a:bodyPr wrap="square" lIns="27432" tIns="22860" rIns="27432" bIns="22860" rtlCol="0" anchor="ctr"/>
+          <a:lstStyle/>
+          <a:p>
+            <a:pPr algn="ctr"/>
+            <a:r>
+              <a:rPr sz="1100" b="0" i="1" dirty="0">
+                <a:solidFill>
+                  <a:srgbClr val="5C4826"/>
+                </a:solidFill>
+              </a:rPr>
+              <a:t>independent service paths</a:t>
+            </a:r>
+          </a:p>
+        </p:txBody>
+      </p:sp>
+      <p:sp>
+        <p:nvSpPr>
+          <p:cNvPr id="1010" name="Label"/>
+          <p:cNvSpPr txBox="1"/>
+          <p:nvPr/>
+        </p:nvSpPr>
+        <p:spPr>
+          <a:xfrm>
+            <a:off x="548640" y="5102352"/>
+            <a:ext cx="8046720" cy="365760"/>
+          </a:xfrm>
+          <a:prstGeom prst="rect">
+            <a:avLst/>
+          </a:prstGeom>
+          <a:noFill/>
+        </p:spPr>
+        <p:txBody>
+          <a:bodyPr wrap="square" lIns="27432" tIns="22860" rIns="27432" bIns="22860" anchor="t">
+            <a:spAutoFit/>
+          </a:bodyPr>
+          <a:lstStyle/>
+          <a:p>
+            <a:pPr algn="ctr"/>
+            <a:r>
+              <a:rPr sz="1200" b="1" i="1">
+                <a:solidFill>
+                  <a:srgbClr val="5C4826"/>
+                </a:solidFill>
+              </a:rPr>
+              <a:t>How often will each mode occur? Occurrence stays ‘?’ — which modes warrant action even when their probabilities are unknown?</a:t>
+            </a:r>
+          </a:p>
+        </p:txBody>
+      </p:sp>
+    </p:spTree>
+  </p:cSld>
+  <p:clrMapOvr>
+    <a:masterClrMapping/>
+  </p:clrMapOvr>
+</p:sld>
+</file>
+
 <file path=ppt/slides/slide3.xml><?xml version="1.0" encoding="utf-8"?>
 <p:sld xmlns:a="http://schemas.openxmlformats.org/drawingml/2006/main" xmlns:p="http://schemas.openxmlformats.org/presentationml/2006/main" xmlns:r="http://schemas.openxmlformats.org/officeDocument/2006/relationships">
   <p:cSld>
@@ -22089,6 +23605,1310 @@
           </a:fontRef>
         </p:style>
       </p:cxnSp>
+    </p:spTree>
+  </p:cSld>
+  <p:clrMapOvr>
+    <a:masterClrMapping/>
+  </p:clrMapOvr>
+</p:sld>
+</file>
+
+<file path=ppt/slides/slide30.xml><?xml version="1.0" encoding="utf-8"?>
+<p:sld xmlns:a="http://schemas.openxmlformats.org/drawingml/2006/main" xmlns:p="http://schemas.openxmlformats.org/presentationml/2006/main" xmlns:r="http://schemas.openxmlformats.org/officeDocument/2006/relationships">
+  <p:cSld>
+    <p:spTree>
+      <p:nvGrpSpPr>
+        <p:cNvPr id="1" name=""/>
+        <p:cNvGrpSpPr/>
+        <p:nvPr/>
+      </p:nvGrpSpPr>
+      <p:grpSpPr/>
+      <p:sp>
+        <p:nvSpPr>
+          <p:cNvPr id="3" name="Title 2"/>
+          <p:cNvSpPr>
+            <a:spLocks noGrp="1"/>
+          </p:cNvSpPr>
+          <p:nvPr>
+            <p:ph type="title"/>
+          </p:nvPr>
+        </p:nvSpPr>
+        <p:spPr/>
+        <p:txBody>
+          <a:bodyPr>
+            <a:normAutofit fontScale="90000"/>
+          </a:bodyPr>
+          <a:lstStyle/>
+          <a:p>
+            <a:r>
+              <a:rPr sz="2400" b="0" i="0">
+                <a:solidFill>
+                  <a:srgbClr val="000000"/>
+                </a:solidFill>
+              </a:rPr>
+              <a:t>Apply FMEA to an unfamiliar system</a:t>
+            </a:r>
+          </a:p>
+        </p:txBody>
+      </p:sp>
+      <p:sp>
+        <p:nvSpPr>
+          <p:cNvPr id="900" name="Slide Number Placeholder 900"/>
+          <p:cNvSpPr>
+            <a:spLocks noGrp="1"/>
+          </p:cNvSpPr>
+          <p:nvPr>
+            <p:ph type="sldNum" sz="quarter" idx="4"/>
+          </p:nvPr>
+        </p:nvSpPr>
+        <p:spPr/>
+        <p:txBody>
+          <a:bodyPr/>
+          <a:lstStyle/>
+          <a:p>
+            <a:fld id="{8CF8A65D-8523-4C39-BD83-5C787F1FA9B3}" type="slidenum">
+              <a:rPr lang="en-US" smtClean="0"/>
+              <a:t>10</a:t>
+            </a:fld>
+            <a:endParaRPr lang="en-US"/>
+          </a:p>
+        </p:txBody>
+      </p:sp>
+      <p:sp>
+        <p:nvSpPr>
+          <p:cNvPr id="909" name="FooterBand"/>
+          <p:cNvSpPr/>
+          <p:nvPr/>
+        </p:nvSpPr>
+        <p:spPr>
+          <a:xfrm>
+            <a:off x="274320" y="5513831"/>
+            <a:ext cx="8595360" cy="905256"/>
+          </a:xfrm>
+          <a:prstGeom prst="rect">
+            <a:avLst/>
+          </a:prstGeom>
+          <a:solidFill>
+            <a:srgbClr val="8E6F3E"/>
+          </a:solidFill>
+          <a:ln>
+            <a:noFill/>
+          </a:ln>
+          <a:effectLst/>
+        </p:spPr>
+        <p:style>
+          <a:lnRef idx="1">
+            <a:schemeClr val="accent1"/>
+          </a:lnRef>
+          <a:fillRef idx="3">
+            <a:schemeClr val="accent1"/>
+          </a:fillRef>
+          <a:effectRef idx="2">
+            <a:schemeClr val="accent1"/>
+          </a:effectRef>
+          <a:fontRef idx="minor">
+            <a:schemeClr val="lt1"/>
+          </a:fontRef>
+        </p:style>
+        <p:txBody>
+          <a:bodyPr wrap="square" lIns="27432" tIns="22860" rIns="27432" bIns="22860" rtlCol="0" anchor="ctr"/>
+          <a:lstStyle/>
+          <a:p>
+            <a:pPr algn="ctr"/>
+            <a:r>
+              <a:rPr sz="2000" b="1" i="0" dirty="0">
+                <a:solidFill>
+                  <a:srgbClr val="FFFFFF"/>
+                </a:solidFill>
+              </a:rPr>
+              <a:t>YOUR TASK (2–3 minutes, with a partner): at least one failure mode per function.</a:t>
+            </a:r>
+          </a:p>
+          <a:p>
+            <a:pPr algn="ctr">
+              <a:spcBef>
+                <a:spcPts val="300"/>
+              </a:spcBef>
+            </a:pPr>
+            <a:r>
+              <a:rPr sz="2000" b="1" i="0" dirty="0">
+                <a:solidFill>
+                  <a:srgbClr val="FFFFFF"/>
+                </a:solidFill>
+              </a:rPr>
+              <a:t>Leave likelihood as ‘?’ — decide which modes warrant a control anyway.</a:t>
+            </a:r>
+          </a:p>
+        </p:txBody>
+      </p:sp>
+      <p:sp>
+        <p:nvSpPr>
+          <p:cNvPr id="920" name="Block"/>
+          <p:cNvSpPr/>
+          <p:nvPr/>
+        </p:nvSpPr>
+        <p:spPr>
+          <a:xfrm>
+            <a:off x="548640" y="1005840"/>
+            <a:ext cx="2560320" cy="566928"/>
+          </a:xfrm>
+          <a:prstGeom prst="rect">
+            <a:avLst/>
+          </a:prstGeom>
+          <a:solidFill>
+            <a:srgbClr val="8E6F3E"/>
+          </a:solidFill>
+          <a:ln>
+            <a:noFill/>
+          </a:ln>
+          <a:effectLst/>
+        </p:spPr>
+        <p:style>
+          <a:lnRef idx="1">
+            <a:schemeClr val="accent1"/>
+          </a:lnRef>
+          <a:fillRef idx="3">
+            <a:schemeClr val="accent1"/>
+          </a:fillRef>
+          <a:effectRef idx="2">
+            <a:schemeClr val="accent1"/>
+          </a:effectRef>
+          <a:fontRef idx="minor">
+            <a:schemeClr val="lt1"/>
+          </a:fontRef>
+        </p:style>
+        <p:txBody>
+          <a:bodyPr wrap="square" lIns="27432" tIns="22860" rIns="27432" bIns="22860" rtlCol="0" anchor="ctr"/>
+          <a:lstStyle/>
+          <a:p>
+            <a:pPr algn="ctr"/>
+            <a:r>
+              <a:rPr sz="1200" b="1" i="0">
+                <a:solidFill>
+                  <a:srgbClr val="FFFFFF"/>
+                </a:solidFill>
+              </a:rPr>
+              <a:t>CLOUDFLARE</a:t>
+            </a:r>
+          </a:p>
+        </p:txBody>
+      </p:sp>
+      <p:sp>
+        <p:nvSpPr>
+          <p:cNvPr id="921" name="RowCaption"/>
+          <p:cNvSpPr/>
+          <p:nvPr/>
+        </p:nvSpPr>
+        <p:spPr>
+          <a:xfrm>
+            <a:off x="3383280" y="1005840"/>
+            <a:ext cx="5212080" cy="566928"/>
+          </a:xfrm>
+          <a:prstGeom prst="rect">
+            <a:avLst/>
+          </a:prstGeom>
+          <a:noFill/>
+          <a:ln>
+            <a:noFill/>
+          </a:ln>
+          <a:effectLst/>
+        </p:spPr>
+        <p:style>
+          <a:lnRef idx="1">
+            <a:schemeClr val="accent1"/>
+          </a:lnRef>
+          <a:fillRef idx="3">
+            <a:schemeClr val="accent1"/>
+          </a:fillRef>
+          <a:effectRef idx="2">
+            <a:schemeClr val="accent1"/>
+          </a:effectRef>
+          <a:fontRef idx="minor">
+            <a:schemeClr val="lt1"/>
+          </a:fontRef>
+        </p:style>
+        <p:txBody>
+          <a:bodyPr wrap="square" lIns="27432" tIns="22860" rIns="27432" bIns="22860" rtlCol="0" anchor="ctr"/>
+          <a:lstStyle/>
+          <a:p>
+            <a:pPr algn="l"/>
+            <a:r>
+              <a:rPr sz="1600" b="0" i="0">
+                <a:solidFill>
+                  <a:srgbClr val="555960"/>
+                </a:solidFill>
+              </a:rPr>
+              <a:t>operates a Web Application Firewall (WAF): it inspects incoming web requests for attacks</a:t>
+            </a:r>
+          </a:p>
+        </p:txBody>
+      </p:sp>
+      <p:sp>
+        <p:nvSpPr>
+          <p:cNvPr id="923" name="Block"/>
+          <p:cNvSpPr/>
+          <p:nvPr/>
+        </p:nvSpPr>
+        <p:spPr>
+          <a:xfrm>
+            <a:off x="548640" y="1664208"/>
+            <a:ext cx="2560320" cy="566928"/>
+          </a:xfrm>
+          <a:prstGeom prst="rect">
+            <a:avLst/>
+          </a:prstGeom>
+          <a:solidFill>
+            <a:srgbClr val="8E6F3E"/>
+          </a:solidFill>
+          <a:ln>
+            <a:noFill/>
+          </a:ln>
+          <a:effectLst/>
+        </p:spPr>
+        <p:style>
+          <a:lnRef idx="1">
+            <a:schemeClr val="accent1"/>
+          </a:lnRef>
+          <a:fillRef idx="3">
+            <a:schemeClr val="accent1"/>
+          </a:fillRef>
+          <a:effectRef idx="2">
+            <a:schemeClr val="accent1"/>
+          </a:effectRef>
+          <a:fontRef idx="minor">
+            <a:schemeClr val="lt1"/>
+          </a:fontRef>
+        </p:style>
+        <p:txBody>
+          <a:bodyPr wrap="square" lIns="27432" tIns="22860" rIns="27432" bIns="22860" rtlCol="0" anchor="ctr"/>
+          <a:lstStyle/>
+          <a:p>
+            <a:pPr algn="ctr"/>
+            <a:r>
+              <a:rPr sz="1200" b="1" i="0">
+                <a:solidFill>
+                  <a:srgbClr val="FFFFFF"/>
+                </a:solidFill>
+              </a:rPr>
+              <a:t>RULE CHANGES</a:t>
+            </a:r>
+          </a:p>
+        </p:txBody>
+      </p:sp>
+      <p:sp>
+        <p:nvSpPr>
+          <p:cNvPr id="924" name="RowCaption"/>
+          <p:cNvSpPr/>
+          <p:nvPr/>
+        </p:nvSpPr>
+        <p:spPr>
+          <a:xfrm>
+            <a:off x="3383280" y="1664208"/>
+            <a:ext cx="5212080" cy="566928"/>
+          </a:xfrm>
+          <a:prstGeom prst="rect">
+            <a:avLst/>
+          </a:prstGeom>
+          <a:noFill/>
+          <a:ln>
+            <a:noFill/>
+          </a:ln>
+          <a:effectLst/>
+        </p:spPr>
+        <p:style>
+          <a:lnRef idx="1">
+            <a:schemeClr val="accent1"/>
+          </a:lnRef>
+          <a:fillRef idx="3">
+            <a:schemeClr val="accent1"/>
+          </a:fillRef>
+          <a:effectRef idx="2">
+            <a:schemeClr val="accent1"/>
+          </a:effectRef>
+          <a:fontRef idx="minor">
+            <a:schemeClr val="lt1"/>
+          </a:fontRef>
+        </p:style>
+        <p:txBody>
+          <a:bodyPr wrap="square" lIns="27432" tIns="22860" rIns="27432" bIns="22860" rtlCol="0" anchor="ctr"/>
+          <a:lstStyle/>
+          <a:p>
+            <a:pPr algn="l"/>
+            <a:r>
+              <a:rPr sz="1600" b="0" i="0">
+                <a:solidFill>
+                  <a:srgbClr val="555960"/>
+                </a:solidFill>
+              </a:rPr>
+              <a:t>new detection rules deploy without a software release — and propagate globally within seconds</a:t>
+            </a:r>
+          </a:p>
+        </p:txBody>
+      </p:sp>
+      <p:sp>
+        <p:nvSpPr>
+          <p:cNvPr id="926" name="Block"/>
+          <p:cNvSpPr/>
+          <p:nvPr/>
+        </p:nvSpPr>
+        <p:spPr>
+          <a:xfrm>
+            <a:off x="548640" y="2322576"/>
+            <a:ext cx="2560320" cy="566928"/>
+          </a:xfrm>
+          <a:prstGeom prst="rect">
+            <a:avLst/>
+          </a:prstGeom>
+          <a:solidFill>
+            <a:srgbClr val="8E6F3E"/>
+          </a:solidFill>
+          <a:ln>
+            <a:noFill/>
+          </a:ln>
+          <a:effectLst/>
+        </p:spPr>
+        <p:style>
+          <a:lnRef idx="1">
+            <a:schemeClr val="accent1"/>
+          </a:lnRef>
+          <a:fillRef idx="3">
+            <a:schemeClr val="accent1"/>
+          </a:fillRef>
+          <a:effectRef idx="2">
+            <a:schemeClr val="accent1"/>
+          </a:effectRef>
+          <a:fontRef idx="minor">
+            <a:schemeClr val="lt1"/>
+          </a:fontRef>
+        </p:style>
+        <p:txBody>
+          <a:bodyPr wrap="square" lIns="27432" tIns="22860" rIns="27432" bIns="22860" rtlCol="0" anchor="ctr"/>
+          <a:lstStyle/>
+          <a:p>
+            <a:pPr algn="ctr"/>
+            <a:r>
+              <a:rPr sz="1200" b="1" i="0" dirty="0">
+                <a:solidFill>
+                  <a:srgbClr val="FFFFFF"/>
+                </a:solidFill>
+              </a:rPr>
+              <a:t>RULE FORM</a:t>
+            </a:r>
+          </a:p>
+        </p:txBody>
+      </p:sp>
+      <p:sp>
+        <p:nvSpPr>
+          <p:cNvPr id="927" name="RowCaption"/>
+          <p:cNvSpPr/>
+          <p:nvPr/>
+        </p:nvSpPr>
+        <p:spPr>
+          <a:xfrm>
+            <a:off x="3383280" y="2322576"/>
+            <a:ext cx="5212080" cy="566928"/>
+          </a:xfrm>
+          <a:prstGeom prst="rect">
+            <a:avLst/>
+          </a:prstGeom>
+          <a:noFill/>
+          <a:ln>
+            <a:noFill/>
+          </a:ln>
+          <a:effectLst/>
+        </p:spPr>
+        <p:style>
+          <a:lnRef idx="1">
+            <a:schemeClr val="accent1"/>
+          </a:lnRef>
+          <a:fillRef idx="3">
+            <a:schemeClr val="accent1"/>
+          </a:fillRef>
+          <a:effectRef idx="2">
+            <a:schemeClr val="accent1"/>
+          </a:effectRef>
+          <a:fontRef idx="minor">
+            <a:schemeClr val="lt1"/>
+          </a:fontRef>
+        </p:style>
+        <p:txBody>
+          <a:bodyPr wrap="square" lIns="27432" tIns="22860" rIns="27432" bIns="22860" rtlCol="0" anchor="ctr"/>
+          <a:lstStyle/>
+          <a:p>
+            <a:pPr algn="l"/>
+            <a:r>
+              <a:rPr sz="1600" b="0" i="0">
+                <a:solidFill>
+                  <a:srgbClr val="555960"/>
+                </a:solidFill>
+              </a:rPr>
+              <a:t>some detection rules are written as regular expressions</a:t>
+            </a:r>
+          </a:p>
+        </p:txBody>
+      </p:sp>
+      <p:sp>
+        <p:nvSpPr>
+          <p:cNvPr id="5" name="ColumnHeading"/>
+          <p:cNvSpPr/>
+          <p:nvPr/>
+        </p:nvSpPr>
+        <p:spPr>
+          <a:xfrm>
+            <a:off x="365760" y="3072384"/>
+            <a:ext cx="1645920" cy="256032"/>
+          </a:xfrm>
+          <a:prstGeom prst="rect">
+            <a:avLst/>
+          </a:prstGeom>
+          <a:noFill/>
+          <a:ln>
+            <a:noFill/>
+          </a:ln>
+          <a:effectLst/>
+        </p:spPr>
+        <p:style>
+          <a:lnRef idx="1">
+            <a:schemeClr val="accent1"/>
+          </a:lnRef>
+          <a:fillRef idx="3">
+            <a:schemeClr val="accent1"/>
+          </a:fillRef>
+          <a:effectRef idx="2">
+            <a:schemeClr val="accent1"/>
+          </a:effectRef>
+          <a:fontRef idx="minor">
+            <a:schemeClr val="lt1"/>
+          </a:fontRef>
+        </p:style>
+        <p:txBody>
+          <a:bodyPr wrap="square" lIns="27432" tIns="22860" rIns="27432" bIns="22860" rtlCol="0" anchor="ctr"/>
+          <a:lstStyle/>
+          <a:p>
+            <a:pPr algn="ctr"/>
+            <a:r>
+              <a:rPr lang="en-US" sz="1200" b="1" i="0" dirty="0">
+                <a:solidFill>
+                  <a:schemeClr val="bg1"/>
+                </a:solidFill>
+              </a:rPr>
+              <a:t>FUNCTION</a:t>
+            </a:r>
+            <a:endParaRPr sz="2800" b="1" i="0" dirty="0">
+              <a:solidFill>
+                <a:schemeClr val="bg1"/>
+              </a:solidFill>
+            </a:endParaRPr>
+          </a:p>
+        </p:txBody>
+      </p:sp>
+      <p:sp>
+        <p:nvSpPr>
+          <p:cNvPr id="1000" name="ColumnHeading"/>
+          <p:cNvSpPr/>
+          <p:nvPr/>
+        </p:nvSpPr>
+        <p:spPr>
+          <a:xfrm>
+            <a:off x="2103120" y="3072384"/>
+            <a:ext cx="2194560" cy="256032"/>
+          </a:xfrm>
+          <a:prstGeom prst="rect">
+            <a:avLst/>
+          </a:prstGeom>
+          <a:noFill/>
+          <a:ln>
+            <a:noFill/>
+          </a:ln>
+          <a:effectLst/>
+        </p:spPr>
+        <p:style>
+          <a:lnRef idx="1">
+            <a:schemeClr val="accent1"/>
+          </a:lnRef>
+          <a:fillRef idx="3">
+            <a:schemeClr val="accent1"/>
+          </a:fillRef>
+          <a:effectRef idx="2">
+            <a:schemeClr val="accent1"/>
+          </a:effectRef>
+          <a:fontRef idx="minor">
+            <a:schemeClr val="lt1"/>
+          </a:fontRef>
+        </p:style>
+        <p:txBody>
+          <a:bodyPr wrap="square" lIns="27432" tIns="22860" rIns="27432" bIns="22860" rtlCol="0" anchor="ctr"/>
+          <a:lstStyle/>
+          <a:p>
+            <a:pPr algn="ctr"/>
+            <a:r>
+              <a:rPr lang="en-US" sz="1200" b="1" i="0" dirty="0">
+                <a:solidFill>
+                  <a:schemeClr val="bg1"/>
+                </a:solidFill>
+              </a:rPr>
+              <a:t>POSSIBLE FAILURE MODE</a:t>
+            </a:r>
+            <a:endParaRPr sz="2800" b="1" i="0" dirty="0">
+              <a:solidFill>
+                <a:schemeClr val="bg1"/>
+              </a:solidFill>
+            </a:endParaRPr>
+          </a:p>
+        </p:txBody>
+      </p:sp>
+      <p:sp>
+        <p:nvSpPr>
+          <p:cNvPr id="1001" name="ColumnHeading"/>
+          <p:cNvSpPr/>
+          <p:nvPr/>
+        </p:nvSpPr>
+        <p:spPr>
+          <a:xfrm>
+            <a:off x="4389120" y="3072384"/>
+            <a:ext cx="2011680" cy="256032"/>
+          </a:xfrm>
+          <a:prstGeom prst="rect">
+            <a:avLst/>
+          </a:prstGeom>
+          <a:noFill/>
+          <a:ln>
+            <a:noFill/>
+          </a:ln>
+          <a:effectLst/>
+        </p:spPr>
+        <p:style>
+          <a:lnRef idx="1">
+            <a:schemeClr val="accent1"/>
+          </a:lnRef>
+          <a:fillRef idx="3">
+            <a:schemeClr val="accent1"/>
+          </a:fillRef>
+          <a:effectRef idx="2">
+            <a:schemeClr val="accent1"/>
+          </a:effectRef>
+          <a:fontRef idx="minor">
+            <a:schemeClr val="lt1"/>
+          </a:fontRef>
+        </p:style>
+        <p:txBody>
+          <a:bodyPr wrap="square" lIns="27432" tIns="22860" rIns="27432" bIns="22860" rtlCol="0" anchor="ctr"/>
+          <a:lstStyle/>
+          <a:p>
+            <a:pPr algn="ctr"/>
+            <a:r>
+              <a:rPr lang="en-US" sz="1200" b="1" i="0" dirty="0">
+                <a:solidFill>
+                  <a:schemeClr val="bg1"/>
+                </a:solidFill>
+              </a:rPr>
+              <a:t>POTENTIAL EFFECT</a:t>
+            </a:r>
+            <a:endParaRPr sz="2800" b="1" i="0" dirty="0">
+              <a:solidFill>
+                <a:schemeClr val="bg1"/>
+              </a:solidFill>
+            </a:endParaRPr>
+          </a:p>
+        </p:txBody>
+      </p:sp>
+      <p:sp>
+        <p:nvSpPr>
+          <p:cNvPr id="1002" name="ColumnHeading"/>
+          <p:cNvSpPr/>
+          <p:nvPr/>
+        </p:nvSpPr>
+        <p:spPr>
+          <a:xfrm>
+            <a:off x="6492240" y="3072384"/>
+            <a:ext cx="2103120" cy="256032"/>
+          </a:xfrm>
+          <a:prstGeom prst="rect">
+            <a:avLst/>
+          </a:prstGeom>
+          <a:noFill/>
+          <a:ln>
+            <a:noFill/>
+          </a:ln>
+          <a:effectLst/>
+        </p:spPr>
+        <p:style>
+          <a:lnRef idx="1">
+            <a:schemeClr val="accent1"/>
+          </a:lnRef>
+          <a:fillRef idx="3">
+            <a:schemeClr val="accent1"/>
+          </a:fillRef>
+          <a:effectRef idx="2">
+            <a:schemeClr val="accent1"/>
+          </a:effectRef>
+          <a:fontRef idx="minor">
+            <a:schemeClr val="lt1"/>
+          </a:fontRef>
+        </p:style>
+        <p:txBody>
+          <a:bodyPr wrap="square" lIns="27432" tIns="22860" rIns="27432" bIns="22860" rtlCol="0" anchor="ctr"/>
+          <a:lstStyle/>
+          <a:p>
+            <a:pPr algn="ctr"/>
+            <a:r>
+              <a:rPr lang="en-US" sz="1200" b="1" i="0" dirty="0">
+                <a:solidFill>
+                  <a:schemeClr val="bg1"/>
+                </a:solidFill>
+              </a:rPr>
+              <a:t>PROPOSED CONTROL</a:t>
+            </a:r>
+            <a:endParaRPr sz="2800" b="1" i="0" dirty="0">
+              <a:solidFill>
+                <a:schemeClr val="bg1"/>
+              </a:solidFill>
+            </a:endParaRPr>
+          </a:p>
+        </p:txBody>
+      </p:sp>
+      <p:sp>
+        <p:nvSpPr>
+          <p:cNvPr id="1003" name="Block"/>
+          <p:cNvSpPr/>
+          <p:nvPr/>
+        </p:nvSpPr>
+        <p:spPr>
+          <a:xfrm>
+            <a:off x="365760" y="3401568"/>
+            <a:ext cx="1645920" cy="603504"/>
+          </a:xfrm>
+          <a:prstGeom prst="rect">
+            <a:avLst/>
+          </a:prstGeom>
+          <a:solidFill>
+            <a:srgbClr val="8E6F3E"/>
+          </a:solidFill>
+          <a:ln>
+            <a:noFill/>
+          </a:ln>
+          <a:effectLst/>
+        </p:spPr>
+        <p:style>
+          <a:lnRef idx="1">
+            <a:schemeClr val="accent1"/>
+          </a:lnRef>
+          <a:fillRef idx="3">
+            <a:schemeClr val="accent1"/>
+          </a:fillRef>
+          <a:effectRef idx="2">
+            <a:schemeClr val="accent1"/>
+          </a:effectRef>
+          <a:fontRef idx="minor">
+            <a:schemeClr val="lt1"/>
+          </a:fontRef>
+        </p:style>
+        <p:txBody>
+          <a:bodyPr wrap="square" lIns="27432" tIns="22860" rIns="27432" bIns="22860" rtlCol="0" anchor="ctr"/>
+          <a:lstStyle/>
+          <a:p>
+            <a:pPr algn="ctr"/>
+            <a:r>
+              <a:rPr sz="1200" b="1" i="0">
+                <a:solidFill>
+                  <a:srgbClr val="FFFFFF"/>
+                </a:solidFill>
+              </a:rPr>
+              <a:t>Evaluate WAF rule</a:t>
+            </a:r>
+          </a:p>
+        </p:txBody>
+      </p:sp>
+      <p:sp>
+        <p:nvSpPr>
+          <p:cNvPr id="1004" name="Block"/>
+          <p:cNvSpPr/>
+          <p:nvPr/>
+        </p:nvSpPr>
+        <p:spPr>
+          <a:xfrm>
+            <a:off x="365760" y="4059936"/>
+            <a:ext cx="1645920" cy="603504"/>
+          </a:xfrm>
+          <a:prstGeom prst="rect">
+            <a:avLst/>
+          </a:prstGeom>
+          <a:solidFill>
+            <a:srgbClr val="8E6F3E"/>
+          </a:solidFill>
+          <a:ln>
+            <a:noFill/>
+          </a:ln>
+          <a:effectLst/>
+        </p:spPr>
+        <p:style>
+          <a:lnRef idx="1">
+            <a:schemeClr val="accent1"/>
+          </a:lnRef>
+          <a:fillRef idx="3">
+            <a:schemeClr val="accent1"/>
+          </a:fillRef>
+          <a:effectRef idx="2">
+            <a:schemeClr val="accent1"/>
+          </a:effectRef>
+          <a:fontRef idx="minor">
+            <a:schemeClr val="lt1"/>
+          </a:fontRef>
+        </p:style>
+        <p:txBody>
+          <a:bodyPr wrap="square" lIns="27432" tIns="22860" rIns="27432" bIns="22860" rtlCol="0" anchor="ctr"/>
+          <a:lstStyle/>
+          <a:p>
+            <a:pPr algn="ctr"/>
+            <a:r>
+              <a:rPr sz="1200" b="1" i="0">
+                <a:solidFill>
+                  <a:srgbClr val="FFFFFF"/>
+                </a:solidFill>
+              </a:rPr>
+              <a:t>Validate new rule</a:t>
+            </a:r>
+          </a:p>
+        </p:txBody>
+      </p:sp>
+      <p:sp>
+        <p:nvSpPr>
+          <p:cNvPr id="1005" name="Block"/>
+          <p:cNvSpPr/>
+          <p:nvPr/>
+        </p:nvSpPr>
+        <p:spPr>
+          <a:xfrm>
+            <a:off x="365760" y="4718304"/>
+            <a:ext cx="1645920" cy="603504"/>
+          </a:xfrm>
+          <a:prstGeom prst="rect">
+            <a:avLst/>
+          </a:prstGeom>
+          <a:solidFill>
+            <a:srgbClr val="8E6F3E"/>
+          </a:solidFill>
+          <a:ln>
+            <a:noFill/>
+          </a:ln>
+          <a:effectLst/>
+        </p:spPr>
+        <p:style>
+          <a:lnRef idx="1">
+            <a:schemeClr val="accent1"/>
+          </a:lnRef>
+          <a:fillRef idx="3">
+            <a:schemeClr val="accent1"/>
+          </a:fillRef>
+          <a:effectRef idx="2">
+            <a:schemeClr val="accent1"/>
+          </a:effectRef>
+          <a:fontRef idx="minor">
+            <a:schemeClr val="lt1"/>
+          </a:fontRef>
+        </p:style>
+        <p:txBody>
+          <a:bodyPr wrap="square" lIns="27432" tIns="22860" rIns="27432" bIns="22860" rtlCol="0" anchor="ctr"/>
+          <a:lstStyle/>
+          <a:p>
+            <a:pPr algn="ctr"/>
+            <a:r>
+              <a:rPr sz="1200" b="1" i="0">
+                <a:solidFill>
+                  <a:srgbClr val="FFFFFF"/>
+                </a:solidFill>
+              </a:rPr>
+              <a:t>Distribute rule</a:t>
+            </a:r>
+          </a:p>
+        </p:txBody>
+      </p:sp>
+      <p:sp>
+        <p:nvSpPr>
+          <p:cNvPr id="903" name="Card"/>
+          <p:cNvSpPr/>
+          <p:nvPr/>
+        </p:nvSpPr>
+        <p:spPr>
+          <a:xfrm>
+            <a:off x="2103120" y="3401568"/>
+            <a:ext cx="2194560" cy="603504"/>
+          </a:xfrm>
+          <a:prstGeom prst="rect">
+            <a:avLst/>
+          </a:prstGeom>
+          <a:solidFill>
+            <a:srgbClr val="F5F1E8"/>
+          </a:solidFill>
+          <a:ln w="12700">
+            <a:solidFill>
+              <a:srgbClr val="C9B991"/>
+            </a:solidFill>
+          </a:ln>
+          <a:effectLst/>
+        </p:spPr>
+        <p:style>
+          <a:lnRef idx="1">
+            <a:schemeClr val="accent1"/>
+          </a:lnRef>
+          <a:fillRef idx="3">
+            <a:schemeClr val="accent1"/>
+          </a:fillRef>
+          <a:effectRef idx="2">
+            <a:schemeClr val="accent1"/>
+          </a:effectRef>
+          <a:fontRef idx="minor">
+            <a:schemeClr val="lt1"/>
+          </a:fontRef>
+        </p:style>
+        <p:txBody>
+          <a:bodyPr wrap="square" lIns="27432" tIns="22860" rIns="27432" bIns="22860" rtlCol="0" anchor="ctr"/>
+          <a:lstStyle/>
+          <a:p>
+            <a:pPr algn="ctr"/>
+            <a:r>
+              <a:rPr sz="2000" b="0" i="1" dirty="0">
+                <a:solidFill>
+                  <a:srgbClr val="5C4826"/>
+                </a:solidFill>
+              </a:rPr>
+              <a:t/>
+            </a:r>
+          </a:p>
+        </p:txBody>
+      </p:sp>
+      <p:sp>
+        <p:nvSpPr>
+          <p:cNvPr id="1006" name="Card"/>
+          <p:cNvSpPr/>
+          <p:nvPr/>
+        </p:nvSpPr>
+        <p:spPr>
+          <a:xfrm>
+            <a:off x="4389120" y="3401568"/>
+            <a:ext cx="2011680" cy="603504"/>
+          </a:xfrm>
+          <a:prstGeom prst="rect">
+            <a:avLst/>
+          </a:prstGeom>
+          <a:solidFill>
+            <a:srgbClr val="F5F1E8"/>
+          </a:solidFill>
+          <a:ln w="12700">
+            <a:solidFill>
+              <a:srgbClr val="C9B991"/>
+            </a:solidFill>
+          </a:ln>
+          <a:effectLst/>
+        </p:spPr>
+        <p:style>
+          <a:lnRef idx="1">
+            <a:schemeClr val="accent1"/>
+          </a:lnRef>
+          <a:fillRef idx="3">
+            <a:schemeClr val="accent1"/>
+          </a:fillRef>
+          <a:effectRef idx="2">
+            <a:schemeClr val="accent1"/>
+          </a:effectRef>
+          <a:fontRef idx="minor">
+            <a:schemeClr val="lt1"/>
+          </a:fontRef>
+        </p:style>
+        <p:txBody>
+          <a:bodyPr wrap="square" lIns="27432" tIns="22860" rIns="27432" bIns="22860" rtlCol="0" anchor="ctr"/>
+          <a:lstStyle/>
+          <a:p>
+            <a:pPr algn="ctr"/>
+            <a:r>
+              <a:rPr sz="2000" b="0" i="1" dirty="0">
+                <a:solidFill>
+                  <a:srgbClr val="5C4826"/>
+                </a:solidFill>
+              </a:rPr>
+              <a:t/>
+            </a:r>
+          </a:p>
+        </p:txBody>
+      </p:sp>
+      <p:sp>
+        <p:nvSpPr>
+          <p:cNvPr id="1007" name="Card"/>
+          <p:cNvSpPr/>
+          <p:nvPr/>
+        </p:nvSpPr>
+        <p:spPr>
+          <a:xfrm>
+            <a:off x="6492240" y="3401568"/>
+            <a:ext cx="2103120" cy="603504"/>
+          </a:xfrm>
+          <a:prstGeom prst="rect">
+            <a:avLst/>
+          </a:prstGeom>
+          <a:solidFill>
+            <a:srgbClr val="F5F1E8"/>
+          </a:solidFill>
+          <a:ln w="12700">
+            <a:solidFill>
+              <a:srgbClr val="C9B991"/>
+            </a:solidFill>
+          </a:ln>
+          <a:effectLst/>
+        </p:spPr>
+        <p:style>
+          <a:lnRef idx="1">
+            <a:schemeClr val="accent1"/>
+          </a:lnRef>
+          <a:fillRef idx="3">
+            <a:schemeClr val="accent1"/>
+          </a:fillRef>
+          <a:effectRef idx="2">
+            <a:schemeClr val="accent1"/>
+          </a:effectRef>
+          <a:fontRef idx="minor">
+            <a:schemeClr val="lt1"/>
+          </a:fontRef>
+        </p:style>
+        <p:txBody>
+          <a:bodyPr wrap="square" lIns="27432" tIns="22860" rIns="27432" bIns="22860" rtlCol="0" anchor="ctr"/>
+          <a:lstStyle/>
+          <a:p>
+            <a:pPr algn="ctr"/>
+            <a:r>
+              <a:rPr sz="2000" b="0" i="1" dirty="0">
+                <a:solidFill>
+                  <a:srgbClr val="5C4826"/>
+                </a:solidFill>
+              </a:rPr>
+              <a:t/>
+            </a:r>
+          </a:p>
+        </p:txBody>
+      </p:sp>
+      <p:sp>
+        <p:nvSpPr>
+          <p:cNvPr id="1008" name="Card"/>
+          <p:cNvSpPr/>
+          <p:nvPr/>
+        </p:nvSpPr>
+        <p:spPr>
+          <a:xfrm>
+            <a:off x="2103120" y="4059936"/>
+            <a:ext cx="2194560" cy="603504"/>
+          </a:xfrm>
+          <a:prstGeom prst="rect">
+            <a:avLst/>
+          </a:prstGeom>
+          <a:solidFill>
+            <a:srgbClr val="F5F1E8"/>
+          </a:solidFill>
+          <a:ln w="12700">
+            <a:solidFill>
+              <a:srgbClr val="C9B991"/>
+            </a:solidFill>
+          </a:ln>
+          <a:effectLst/>
+        </p:spPr>
+        <p:style>
+          <a:lnRef idx="1">
+            <a:schemeClr val="accent1"/>
+          </a:lnRef>
+          <a:fillRef idx="3">
+            <a:schemeClr val="accent1"/>
+          </a:fillRef>
+          <a:effectRef idx="2">
+            <a:schemeClr val="accent1"/>
+          </a:effectRef>
+          <a:fontRef idx="minor">
+            <a:schemeClr val="lt1"/>
+          </a:fontRef>
+        </p:style>
+        <p:txBody>
+          <a:bodyPr wrap="square" lIns="27432" tIns="22860" rIns="27432" bIns="22860" rtlCol="0" anchor="ctr"/>
+          <a:lstStyle/>
+          <a:p>
+            <a:pPr algn="ctr"/>
+            <a:r>
+              <a:rPr sz="2000" b="0" i="1" dirty="0">
+                <a:solidFill>
+                  <a:srgbClr val="5C4826"/>
+                </a:solidFill>
+              </a:rPr>
+              <a:t/>
+            </a:r>
+          </a:p>
+        </p:txBody>
+      </p:sp>
+      <p:sp>
+        <p:nvSpPr>
+          <p:cNvPr id="1009" name="Card"/>
+          <p:cNvSpPr/>
+          <p:nvPr/>
+        </p:nvSpPr>
+        <p:spPr>
+          <a:xfrm>
+            <a:off x="4389120" y="4059936"/>
+            <a:ext cx="2011680" cy="603504"/>
+          </a:xfrm>
+          <a:prstGeom prst="rect">
+            <a:avLst/>
+          </a:prstGeom>
+          <a:solidFill>
+            <a:srgbClr val="F5F1E8"/>
+          </a:solidFill>
+          <a:ln w="12700">
+            <a:solidFill>
+              <a:srgbClr val="C9B991"/>
+            </a:solidFill>
+          </a:ln>
+          <a:effectLst/>
+        </p:spPr>
+        <p:style>
+          <a:lnRef idx="1">
+            <a:schemeClr val="accent1"/>
+          </a:lnRef>
+          <a:fillRef idx="3">
+            <a:schemeClr val="accent1"/>
+          </a:fillRef>
+          <a:effectRef idx="2">
+            <a:schemeClr val="accent1"/>
+          </a:effectRef>
+          <a:fontRef idx="minor">
+            <a:schemeClr val="lt1"/>
+          </a:fontRef>
+        </p:style>
+        <p:txBody>
+          <a:bodyPr wrap="square" lIns="27432" tIns="22860" rIns="27432" bIns="22860" rtlCol="0" anchor="ctr"/>
+          <a:lstStyle/>
+          <a:p>
+            <a:pPr algn="ctr"/>
+            <a:r>
+              <a:rPr sz="2000" b="0" i="1" dirty="0">
+                <a:solidFill>
+                  <a:srgbClr val="5C4826"/>
+                </a:solidFill>
+              </a:rPr>
+              <a:t/>
+            </a:r>
+          </a:p>
+        </p:txBody>
+      </p:sp>
+      <p:sp>
+        <p:nvSpPr>
+          <p:cNvPr id="1010" name="Card"/>
+          <p:cNvSpPr/>
+          <p:nvPr/>
+        </p:nvSpPr>
+        <p:spPr>
+          <a:xfrm>
+            <a:off x="6492240" y="4059936"/>
+            <a:ext cx="2103120" cy="603504"/>
+          </a:xfrm>
+          <a:prstGeom prst="rect">
+            <a:avLst/>
+          </a:prstGeom>
+          <a:solidFill>
+            <a:srgbClr val="F5F1E8"/>
+          </a:solidFill>
+          <a:ln w="12700">
+            <a:solidFill>
+              <a:srgbClr val="C9B991"/>
+            </a:solidFill>
+          </a:ln>
+          <a:effectLst/>
+        </p:spPr>
+        <p:style>
+          <a:lnRef idx="1">
+            <a:schemeClr val="accent1"/>
+          </a:lnRef>
+          <a:fillRef idx="3">
+            <a:schemeClr val="accent1"/>
+          </a:fillRef>
+          <a:effectRef idx="2">
+            <a:schemeClr val="accent1"/>
+          </a:effectRef>
+          <a:fontRef idx="minor">
+            <a:schemeClr val="lt1"/>
+          </a:fontRef>
+        </p:style>
+        <p:txBody>
+          <a:bodyPr wrap="square" lIns="27432" tIns="22860" rIns="27432" bIns="22860" rtlCol="0" anchor="ctr"/>
+          <a:lstStyle/>
+          <a:p>
+            <a:pPr algn="ctr"/>
+            <a:r>
+              <a:rPr sz="2000" b="0" i="1" dirty="0">
+                <a:solidFill>
+                  <a:srgbClr val="5C4826"/>
+                </a:solidFill>
+              </a:rPr>
+              <a:t/>
+            </a:r>
+          </a:p>
+        </p:txBody>
+      </p:sp>
+      <p:sp>
+        <p:nvSpPr>
+          <p:cNvPr id="1011" name="Card"/>
+          <p:cNvSpPr/>
+          <p:nvPr/>
+        </p:nvSpPr>
+        <p:spPr>
+          <a:xfrm>
+            <a:off x="2103120" y="4718304"/>
+            <a:ext cx="2194560" cy="603504"/>
+          </a:xfrm>
+          <a:prstGeom prst="rect">
+            <a:avLst/>
+          </a:prstGeom>
+          <a:solidFill>
+            <a:srgbClr val="F5F1E8"/>
+          </a:solidFill>
+          <a:ln w="12700">
+            <a:solidFill>
+              <a:srgbClr val="C9B991"/>
+            </a:solidFill>
+          </a:ln>
+          <a:effectLst/>
+        </p:spPr>
+        <p:style>
+          <a:lnRef idx="1">
+            <a:schemeClr val="accent1"/>
+          </a:lnRef>
+          <a:fillRef idx="3">
+            <a:schemeClr val="accent1"/>
+          </a:fillRef>
+          <a:effectRef idx="2">
+            <a:schemeClr val="accent1"/>
+          </a:effectRef>
+          <a:fontRef idx="minor">
+            <a:schemeClr val="lt1"/>
+          </a:fontRef>
+        </p:style>
+        <p:txBody>
+          <a:bodyPr wrap="square" lIns="27432" tIns="22860" rIns="27432" bIns="22860" rtlCol="0" anchor="ctr"/>
+          <a:lstStyle/>
+          <a:p>
+            <a:pPr algn="ctr"/>
+            <a:r>
+              <a:rPr sz="2000" b="0" i="1" dirty="0">
+                <a:solidFill>
+                  <a:srgbClr val="5C4826"/>
+                </a:solidFill>
+              </a:rPr>
+              <a:t/>
+            </a:r>
+          </a:p>
+        </p:txBody>
+      </p:sp>
+      <p:sp>
+        <p:nvSpPr>
+          <p:cNvPr id="1012" name="Card"/>
+          <p:cNvSpPr/>
+          <p:nvPr/>
+        </p:nvSpPr>
+        <p:spPr>
+          <a:xfrm>
+            <a:off x="4389120" y="4718304"/>
+            <a:ext cx="2011680" cy="603504"/>
+          </a:xfrm>
+          <a:prstGeom prst="rect">
+            <a:avLst/>
+          </a:prstGeom>
+          <a:solidFill>
+            <a:srgbClr val="F5F1E8"/>
+          </a:solidFill>
+          <a:ln w="12700">
+            <a:solidFill>
+              <a:srgbClr val="C9B991"/>
+            </a:solidFill>
+          </a:ln>
+          <a:effectLst/>
+        </p:spPr>
+        <p:style>
+          <a:lnRef idx="1">
+            <a:schemeClr val="accent1"/>
+          </a:lnRef>
+          <a:fillRef idx="3">
+            <a:schemeClr val="accent1"/>
+          </a:fillRef>
+          <a:effectRef idx="2">
+            <a:schemeClr val="accent1"/>
+          </a:effectRef>
+          <a:fontRef idx="minor">
+            <a:schemeClr val="lt1"/>
+          </a:fontRef>
+        </p:style>
+        <p:txBody>
+          <a:bodyPr wrap="square" lIns="27432" tIns="22860" rIns="27432" bIns="22860" rtlCol="0" anchor="ctr"/>
+          <a:lstStyle/>
+          <a:p>
+            <a:pPr algn="ctr"/>
+            <a:r>
+              <a:rPr sz="2000" b="0" i="1" dirty="0">
+                <a:solidFill>
+                  <a:srgbClr val="5C4826"/>
+                </a:solidFill>
+              </a:rPr>
+              <a:t/>
+            </a:r>
+          </a:p>
+        </p:txBody>
+      </p:sp>
+      <p:sp>
+        <p:nvSpPr>
+          <p:cNvPr id="1013" name="Card"/>
+          <p:cNvSpPr/>
+          <p:nvPr/>
+        </p:nvSpPr>
+        <p:spPr>
+          <a:xfrm>
+            <a:off x="6492240" y="4718304"/>
+            <a:ext cx="2103120" cy="603504"/>
+          </a:xfrm>
+          <a:prstGeom prst="rect">
+            <a:avLst/>
+          </a:prstGeom>
+          <a:solidFill>
+            <a:srgbClr val="F5F1E8"/>
+          </a:solidFill>
+          <a:ln w="12700">
+            <a:solidFill>
+              <a:srgbClr val="C9B991"/>
+            </a:solidFill>
+          </a:ln>
+          <a:effectLst/>
+        </p:spPr>
+        <p:style>
+          <a:lnRef idx="1">
+            <a:schemeClr val="accent1"/>
+          </a:lnRef>
+          <a:fillRef idx="3">
+            <a:schemeClr val="accent1"/>
+          </a:fillRef>
+          <a:effectRef idx="2">
+            <a:schemeClr val="accent1"/>
+          </a:effectRef>
+          <a:fontRef idx="minor">
+            <a:schemeClr val="lt1"/>
+          </a:fontRef>
+        </p:style>
+        <p:txBody>
+          <a:bodyPr wrap="square" lIns="27432" tIns="22860" rIns="27432" bIns="22860" rtlCol="0" anchor="ctr"/>
+          <a:lstStyle/>
+          <a:p>
+            <a:pPr algn="ctr"/>
+            <a:r>
+              <a:rPr sz="2000" b="0" i="1" dirty="0">
+                <a:solidFill>
+                  <a:srgbClr val="5C4826"/>
+                </a:solidFill>
+              </a:rPr>
+              <a:t/>
+            </a:r>
+          </a:p>
+        </p:txBody>
+      </p:sp>
     </p:spTree>
   </p:cSld>
   <p:clrMapOvr>

</xml_diff>